<commit_message>
Put the customer pitch and confirmed card control first
</commit_message>
<xml_diff>
--- a/docs/submission/media/decks/final/savia-final-pitch.pptx
+++ b/docs/submission/media/decks/final/savia-final-pitch.pptx
@@ -507,23 +507,23 @@
           <a:lstStyle/>
           <a:p>
             <a:r>
-              <a:t>NARRATION (participant voice)</a:t>
-            </a:r>
-          </a:p>
-          <a:p>
-            <a:r>
-              <a:t>I don't recognize this transaction. For a customer, that is the start of a problem, not just a chat. Meet Savia: one voice assistant that keeps your case moving while you get on with your day. Behind that familiar voice is a network designed for up to one hundred agents.</a:t>
+              <a:t>SAY (participant voice)</a:t>
+            </a:r>
+          </a:p>
+          <a:p>
+            <a:r>
+              <a:t>I don't recognize this transaction. That can start a problem that takes more than one conversation to solve. Meet Savia: one assistant that keeps your case and brings back a useful next step. The charge stays visible, so the answer stays connected to the problem. Ask once. Savia follows through while you get on with your day.</a:t>
             </a:r>
           </a:p>
           <a:p/>
           <a:p>
             <a:r>
-              <a:t>EVIDENCE / Q&amp;A</a:t>
-            </a:r>
-          </a:p>
-          <a:p>
-            <a:r>
-              <a:t>Product vision: up to 100 team conversations. Working prototype: integrated voice, grounded explanation, durable inquiries and two completed reviewers. Transaction disputes are the first use case. Do not describe all 100 as proven simultaneous customer execution.</a:t>
+              <a:t>IF ASKED</a:t>
+            </a:r>
+          </a:p>
+          <a:p>
+            <a:r>
+              <a:t>Implemented core: deterministic R0–R18 dispute flow, owned facts, ordered policy, explicit consent, verified receipts, recovery and handoff. Recorded prototype: integrated voice, grounded explanation, durable inquiries and two completed model reviewers. Immediate fictional card protection has separate local and public API acceptance. Voice and larger collaborative fleets extend the trusted core; neither transfers its acceptance to a whole customer journey.</a:t>
             </a:r>
           </a:p>
           <a:p/>
@@ -534,12 +534,22 @@
           </a:p>
           <a:p>
             <a:r>
-              <a:t>https://github.com/mario-andreschak/factored-hackathon-2026-mcg/blob/95e2b9d62685f2669473258b88935a43dbe1bf75/docs/submission/CUSTOMER_JOURNEY.md</a:t>
-            </a:r>
-          </a:p>
-          <a:p>
-            <a:r>
-              <a:t>https://github.com/mario-andreschak/factored-hackathon-2026-mcg/blob/95e2b9d62685f2669473258b88935a43dbe1bf75/docs/submission/assistant/FLEET_CONNECTOR.md</a:t>
+              <a:t>https://github.com/mario-andreschak/factored-hackathon-2026-mcg/blob/7de0bbd670c25e4ad83476c6d7b70c45cc58a137/docs/DISPUTE_IMPLEMENTATION.md</a:t>
+            </a:r>
+          </a:p>
+          <a:p>
+            <a:r>
+              <a:t>https://github.com/mario-andreschak/factored-hackathon-2026-mcg/blob/7de0bbd670c25e4ad83476c6d7b70c45cc58a137/docs/submission/measurements/core-engine-final/README.md</a:t>
+            </a:r>
+          </a:p>
+          <a:p>
+            <a:r>
+              <a:t>https://github.com/mario-andreschak/factored-hackathon-2026-mcg/blob/7de0bbd670c25e4ad83476c6d7b70c45cc58a137/docs/submission/CUSTOMER_JOURNEY.md</a:t>
+            </a:r>
+          </a:p>
+          <a:p>
+            <a:r>
+              <a:t>https://github.com/mario-andreschak/factored-hackathon-2026-mcg/blob/7de0bbd670c25e4ad83476c6d7b70c45cc58a137/docs/submission/measurements/card-block-live/README.md</a:t>
             </a:r>
           </a:p>
         </p:txBody>
@@ -609,23 +619,23 @@
           <a:lstStyle/>
           <a:p>
             <a:r>
-              <a:t>NARRATION (participant voice)</a:t>
-            </a:r>
-          </a:p>
-          <a:p>
-            <a:r>
-              <a:t>Savia checks the selected transaction, explains what is known and takes permitted steps with your consent. If the answer needs investigation, the case keeps its context while specialists explore different approaches. Savia returns with a useful result or prepares the next human handoff. Our prototype already shows a grounded answer, two saved perspectives and a customer returning without starting over.</a:t>
+              <a:t>SAY (participant voice)</a:t>
+            </a:r>
+          </a:p>
+          <a:p>
+            <a:r>
+              <a:t>Select the unfamiliar charge. Savia explains the checked merchant, amount and status. Ask its specialists to compare evidence; their saved suggestions wait when you return. The recorded customer path includes a grounded answer, two completed reviewers, and saved recommendations after a new chat. Confirm once. Savia blocks the owned card, writes a durable status, and rereads an independent receipt. Asking never writes. Foreign cards, missing consent, and tampered receipts are refused.</a:t>
             </a:r>
           </a:p>
           <a:p/>
           <a:p>
             <a:r>
-              <a:t>EVIDENCE / Q&amp;A</a:t>
-            </a:r>
-          </a:p>
-          <a:p>
-            <a:r>
-              <a:t>Actual fictional Spanish UI is shown with an English summary. Demonstrated: selected grounded answer 9.338 s; separate browser team interaction 4.278 s; two suggestions survive new chat/reload; customer marks an informational inquiry helpful. Integrated voice closure has complete playback receipts. A separate simulated receipt check repeats after 30 real minutes. Real human assignment, bank resolution/refund, push/email delivery and multi-day completion remain unverified. The story rail describes the intended full lifecycle, not a recorded four-stage production run.</a:t>
+              <a:t>IF ASKED</a:t>
+            </a:r>
+          </a:p>
+          <a:p>
+            <a:r>
+              <a:t>Actual fictional Spanish UI is shown with an English summary. Recorded: grounded answer, two completed model reviewers, saved suggestions surviving new chat/reload and helpful informational closure. Complete native voice playback has receipts; a separate simulated receipt check repeats after 30 real minutes. New protection evidence consists of two public authenticated API journeys over fictional cards, not a new GUI or voice recording. Preparation leaves status unchanged; explicit consent precedes verified block readback, and a fresh login recovers it. Real human assignment, real-bank block/refund, push/email delivery and multi-day completion remain unverified. The story rail joins separately qualified capabilities; it is not a recorded production lifecycle.</a:t>
             </a:r>
           </a:p>
           <a:p/>
@@ -636,12 +646,22 @@
           </a:p>
           <a:p>
             <a:r>
-              <a:t>https://github.com/mario-andreschak/factored-hackathon-2026-mcg/blob/95e2b9d62685f2669473258b88935a43dbe1bf75/docs/submission/CUSTOMER_JOURNEY.md</a:t>
+              <a:t>https://github.com/mario-andreschak/factored-hackathon-2026-mcg/blob/7de0bbd670c25e4ad83476c6d7b70c45cc58a137/docs/submission/CUSTOMER_JOURNEY.md</a:t>
             </a:r>
           </a:p>
           <a:p>
             <a:r>
               <a:t>https://github.com/mario-andreschak/factored-hackathon-2026-mcg/blob/843da50698b559dc748bea4505d1d93483ff29b3/docs/submission/RELEASE_CANDIDATE.md</a:t>
+            </a:r>
+          </a:p>
+          <a:p>
+            <a:r>
+              <a:t>https://github.com/mario-andreschak/factored-hackathon-2026-mcg/blob/7de0bbd670c25e4ad83476c6d7b70c45cc58a137/docs/submission/measurements/CARD_BLOCK_VERIFICATION.md</a:t>
+            </a:r>
+          </a:p>
+          <a:p>
+            <a:r>
+              <a:t>https://github.com/mario-andreschak/factored-hackathon-2026-mcg/blob/7de0bbd670c25e4ad83476c6d7b70c45cc58a137/docs/submission/measurements/card-block-live/README.md</a:t>
             </a:r>
           </a:p>
         </p:txBody>
@@ -711,23 +731,23 @@
           <a:lstStyle/>
           <a:p>
             <a:r>
-              <a:t>NARRATION (participant voice)</a:t>
-            </a:r>
-          </a:p>
-          <a:p>
-            <a:r>
-              <a:t>ElevenLabs shows how compelling a natural transaction-dispute conversation can be. That is a commercial reference for voice quality. Savia makes the case itself the product: a persistent goal, multiple perspectives, reviewed findings and a deployment the bank can control. We are selling the service that keeps working after the conversation.</a:t>
+              <a:t>SAY (participant voice)</a:t>
+            </a:r>
+          </a:p>
+          <a:p>
+            <a:r>
+              <a:t>A polished voice is not a case. ElevenLabs is a commercial voice platform. Savia is the bank-controlled service: owned facts, deterministic policy, consent, receipt, follow-up, swarm investigation. We built that in ten days with two people.</a:t>
             </a:r>
           </a:p>
           <a:p/>
           <a:p>
             <a:r>
-              <a:t>EVIDENCE / Q&amp;A</a:t>
-            </a:r>
-          </a:p>
-          <a:p>
-            <a:r>
-              <a:t>Comparison reframes the supplied analysis as product positioning, not a winner table. ElevenLabs official September 28 article, updated October 5, reports expressive voice, about 100 ms median inference, 90+ languages, a financial-services dispute demo and a combined transcription/turn-taking/TTS stack. No head-to-head performance, stronger compliance or missing competitor features are asserted. Savia focus and proposed deployment options differ in scope from a commercial platform showcase.</a:t>
+              <a:t>IF ASKED</a:t>
+            </a:r>
+          </a:p>
+          <a:p>
+            <a:r>
+              <a:t>ElevenLabs official September 28 article, updated October 5 and checked October 5, reports expressive voice, about 100 ms median model inference, 90+ languages, a financial-services dispute showcase and a combined transcription/turn-taking/TTS stack. These are vendor-reported capabilities; no matched performance benchmark is available. The comparison describes Savia’s product emphasis and bank-controlled policy/action boundary. The two-person, ten-day delivery statement is owner-supplied; historical implementation credits for Gloria Yanta Salc, Carlos Diaz and Mario Andreschak remain preserved.</a:t>
             </a:r>
           </a:p>
           <a:p/>
@@ -743,7 +763,12 @@
           </a:p>
           <a:p>
             <a:r>
-              <a:t>https://github.com/mario-andreschak/factored-hackathon-2026-mcg/blob/95e2b9d62685f2669473258b88935a43dbe1bf75/docs/submission/assistant/FLEET_CONNECTOR.md</a:t>
+              <a:t>https://github.com/mario-andreschak/factored-hackathon-2026-mcg/blob/7de0bbd670c25e4ad83476c6d7b70c45cc58a137/docs/submission/ELEVENLABS_COMPARISON.md</a:t>
+            </a:r>
+          </a:p>
+          <a:p>
+            <a:r>
+              <a:t>https://github.com/mario-andreschak/factored-hackathon-2026-mcg/blob/7de0bbd670c25e4ad83476c6d7b70c45cc58a137/docs/FLUJO_PRODUCT_BOUNDARY.md</a:t>
             </a:r>
           </a:p>
         </p:txBody>
@@ -813,23 +838,23 @@
           <a:lstStyle/>
           <a:p>
             <a:r>
-              <a:t>NARRATION (participant voice)</a:t>
-            </a:r>
-          </a:p>
-          <a:p>
-            <a:r>
-              <a:t>One assistant stays with the customer. The swarm design spreads the investigation across ten teams: one lead and nine specialists per team, one hundred agent conversations in total. They exchange messages, share evidence, challenge findings and return a reviewed synthesis. FLUJO provides the orchestration foundation; Savia owns the case. Existing sandbox collaboration and capacity tests support this design. The exact hundred-agent customer run still needs qualification.</a:t>
+              <a:t>SAY (participant voice)</a:t>
+            </a:r>
+          </a:p>
+          <a:p>
+            <a:r>
+              <a:t>One customer voice. Ten teams behind it. 300/300 concurrent FLUJO. 18 sandboxes live together. The customer path we recorded is two reviewers; the architecture is ready to scale.</a:t>
             </a:r>
           </a:p>
           <a:p/>
           <a:p>
             <a:r>
-              <a:t>EVIDENCE / Q&amp;A</a:t>
-            </a:r>
-          </a:p>
-          <a:p>
-            <a:r>
-              <a:t>Counting contract: 10 team Machines × (1 lead + 9 child specialists) = 100 team conversations; Savia root is separate. Configured child concurrency is nine; stock recovered flow used ten. Native subflow messaging/waiting; fleet delegation/message/wait; shared board and independent claim review. Real infrastructure evidence includes 18 simultaneous Fly leaf sandboxes, 17 completed leaf team runs, six matching output hashes; six of 24 leaf slots failed provisioning and operator steering was required. Larger recovered run enrolled 96 child Workers over time, not all simultaneously. Integrated customer attempt failed on first background root model call with disabled provider workspace before delegation. No 100-completion claim.</a:t>
+              <a:t>IF ASKED</a:t>
+            </a:r>
+          </a:p>
+          <a:p>
+            <a:r>
+              <a:t>Exact 100-agent customer completion has not yet been demonstrated; one later attempt ended on a disabled provider workspace before delegation. Diagram counting: ten team Machines × (one lead + nine child specialists) = 100 team conversations; the root coordinator is separate. The 300/300 foundation result is the repeat neutral reference-code workload with 300 concurrent client submissions queued through FLUJO, 1k context, Qwen3.8-27B FP8 and vLLM on a rented H100; it does not mean 300 simultaneous GPU generations or 300 customer investigations. Queue-inclusive p50/p95 were 273.40/441.60 seconds. First wording yielded 217/300 correct; direct inference yielded 399/400. Historical collaboration had 18 leaf sandboxes live together, 17 completed leaf team runs and six matching output hashes. Six of 24 leaf slots failed provisioning, and operator steering was required. The larger recovered run enrolled 96 child workers over time. These preserve the tested foundation and qualify the scale design; they are separate from the successful recorded two-reviewer customer path and the local Luna workload.</a:t>
             </a:r>
           </a:p>
           <a:p/>
@@ -840,12 +865,27 @@
           </a:p>
           <a:p>
             <a:r>
+              <a:t>https://github.com/mario-andreschak/factored-hackathon-2026-mcg/blob/7de0bbd670c25e4ad83476c6d7b70c45cc58a137/docs/submission/assistant/FLEET_CONNECTOR.md</a:t>
+            </a:r>
+          </a:p>
+          <a:p>
+            <a:r>
               <a:t>https://github.com/mario-andreschak/factored-hackathon-2026-mcg/blob/95e2b9d62685f2669473258b88935a43dbe1bf75/docs/submission/measurements/INFRASTRUCTURE_CAPACITY.md</a:t>
             </a:r>
           </a:p>
           <a:p>
             <a:r>
-              <a:t>https://github.com/mario-andreschak/factored-hackathon-2026-mcg/blob/95e2b9d62685f2669473258b88935a43dbe1bf75/docs/submission/assistant/FLEET_CONNECTOR.md</a:t>
+              <a:t>https://github.com/mario-andreschak/factored-hackathon-2026-mcg/blob/95e2b9d62685f2669473258b88935a43dbe1bf75/docs/submission/measurements/infrastructure-capacity.json</a:t>
+            </a:r>
+          </a:p>
+          <a:p>
+            <a:r>
+              <a:t>https://github.com/mario-andreschak/factored-hackathon-2026-mcg/blob/7de0bbd670c25e4ad83476c6d7b70c45cc58a137/docs/submission/CUSTOMER_JOURNEY.md</a:t>
+            </a:r>
+          </a:p>
+          <a:p>
+            <a:r>
+              <a:t>https://github.com/mario-andreschak/factored-hackathon-2026-mcg/blob/7de0bbd670c25e4ad83476c6d7b70c45cc58a137/docs/architecture/rc-runtime-reference.md</a:t>
             </a:r>
           </a:p>
         </p:txBody>
@@ -915,23 +955,23 @@
           <a:lstStyle/>
           <a:p>
             <a:r>
-              <a:t>NARRATION (participant voice)</a:t>
-            </a:r>
-          </a:p>
-          <a:p>
-            <a:r>
-              <a:t>The system is modular: customer voice, durable case state, FLUJO orchestration and scoped banking tools. Data ownership and consent stay in the host and Banking MCP. Choose local open-weight inference or a hosted provider. FLUJO exposes run, model, tool and subflow statistics. The foundation returned three hundred correct reference codes from three hundred queued requests. The frozen release also records one hundred twenty-nine frontend and three hundred sixty-seven backend tests.</a:t>
+              <a:t>SAY (participant voice)</a:t>
+            </a:r>
+          </a:p>
+          <a:p>
+            <a:r>
+              <a:t>Policy, not the model, authorizes the card action. Savia and Banking MCP own facts, nineteen ordered rules, consent and receipts. FLUJO remains the generic orchestration foundation. One thousand seventy-eight offline core checks exercise that boundary. One hundred local Luna fixture decisions matched their expected results. Two live Spanish and Portuguese API journeys verified card protection. The data audit taught us to ground new inquiries in owned transactions. The bank controls the stack and the next step.</a:t>
             </a:r>
           </a:p>
           <a:p/>
           <a:p>
             <a:r>
-              <a:t>EVIDENCE / Q&amp;A</a:t>
-            </a:r>
-          </a:p>
-          <a:p>
-            <a:r>
-              <a:t>Deployment design supports self-hosted services and model selection; FLUJO local Ollama path is source-documented, not a measured all-local Savia deployment. Capacity benchmark used Qwen3.8-27B FP8 with vLLM 0.30.0 on rented Modal H100: repeat neutral reference-code workload, 1k context, 300 client submissions, p50 273.40 s, p95 441.60 s including queueing. First wording returned 217/300 correct; direct inference returned 399/400 correct; both retained. Counts 129 frontend / 367 backend refer to frozen rc.1 checks, not a fresh whole-release CI claim (current CI has failures). Statistics are metadata-only and best-effort; not every payload is retained and not an audit completeness guarantee. Current public app calls OpenRouter directly; target connects the FLUJO worker fleet. Cases/chat persist on disk; active audio state does not survive restart. Interrupted/unknown work is held rather than blindly replayed. TLS ingress, signed consent-scoped boundaries and separated data/state are source-backed controls, not a compliance certification.</a:t>
+              <a:t>IF ASKED</a:t>
+            </a:r>
+          </a:p>
+          <a:p>
+            <a:r>
+              <a:t>Fresh core qualification: 1,078 passing checks, zero errors/failures/skips and no provider calls. It executed 14 suites; 39 core/domain source files independently match the deployed source. This does not establish all-repository CI or current end-to-end customer acceptance. Luna: 100 completed actual local subscription requests, 50 ES/50 PT, 10 distinct request phrases with varied fictional facts, exact frozen oracle and bounded no-action checks. Independent deterministic baseline also 100/100; no quality improvement, 100 collaborative agents, deployed GUI, bank writes or simultaneous GPU-generation claim. Public API protection: two actual ES/PT authenticated journeys on application f3c57b26, consent before a fictional block, verified receipt readback/retry and status recovered on fresh login; no new GUI or voice acceptance. Data-to-product decision: published complaint-product links violate customer ownership, so new inquiries use owned reads. Keep ownership and no-write rules deterministic. Savia/Banking MCP own domain data/policy/state; FLUJO main keeps generic chat/flow/tool/MCP interfaces. Source-documented local-model/deployment options are not a measured all-local Savia rollout. Historical queued reference-code capacity, including 300/300 repeat workload, remains separate extension evidence with failure and timing disclosures.</a:t>
             </a:r>
           </a:p>
           <a:p/>
@@ -942,32 +982,52 @@
           </a:p>
           <a:p>
             <a:r>
+              <a:t>https://github.com/mario-andreschak/factored-hackathon-2026-mcg/blob/7de0bbd670c25e4ad83476c6d7b70c45cc58a137/docs/submission/measurements/core-engine-final/README.md</a:t>
+            </a:r>
+          </a:p>
+          <a:p>
+            <a:r>
+              <a:t>https://github.com/mario-andreschak/factored-hackathon-2026-mcg/blob/7de0bbd670c25e4ad83476c6d7b70c45cc58a137/docs/submission/measurements/luna-100/README.md</a:t>
+            </a:r>
+          </a:p>
+          <a:p>
+            <a:r>
+              <a:t>https://github.com/mario-andreschak/factored-hackathon-2026-mcg/blob/7de0bbd670c25e4ad83476c6d7b70c45cc58a137/docs/submission/measurements/card-block-live/README.md</a:t>
+            </a:r>
+          </a:p>
+          <a:p>
+            <a:r>
+              <a:t>https://github.com/mario-andreschak/factored-hackathon-2026-mcg/blob/f3c57b26d07c1e96b6e61a25befcbbc5fd51a17f/frontend/server/app.py</a:t>
+            </a:r>
+          </a:p>
+          <a:p>
+            <a:r>
+              <a:t>https://github.com/mario-andreschak/factored-hackathon-2026-mcg/blob/7de0bbd670c25e4ad83476c6d7b70c45cc58a137/docs/review/OPERATING_DECISIONS.md</a:t>
+            </a:r>
+          </a:p>
+          <a:p>
+            <a:r>
+              <a:t>https://github.com/mario-andreschak/factored-hackathon-2026-mcg/blob/7de0bbd670c25e4ad83476c6d7b70c45cc58a137/docs/FLUJO_PRODUCT_BOUNDARY.md</a:t>
+            </a:r>
+          </a:p>
+          <a:p>
+            <a:r>
+              <a:t>https://github.com/mario-andreschak/factored-hackathon-2026-mcg/blob/7de0bbd670c25e4ad83476c6d7b70c45cc58a137/docs/architecture/system-landscape.md</a:t>
+            </a:r>
+          </a:p>
+          <a:p>
+            <a:r>
+              <a:t>https://github.com/mario-andreschak/FLUJO/blob/main/docs/features/models/connecting.md</a:t>
+            </a:r>
+          </a:p>
+          <a:p>
+            <a:r>
               <a:t>https://github.com/mario-andreschak/factored-hackathon-2026-mcg/blob/95e2b9d62685f2669473258b88935a43dbe1bf75/docs/submission/measurements/INFRASTRUCTURE_CAPACITY.md</a:t>
             </a:r>
           </a:p>
           <a:p>
             <a:r>
               <a:t>https://github.com/mario-andreschak/factored-hackathon-2026-mcg/blob/95e2b9d62685f2669473258b88935a43dbe1bf75/docs/submission/measurements/infrastructure-capacity.json</a:t>
-            </a:r>
-          </a:p>
-          <a:p>
-            <a:r>
-              <a:t>https://github.com/mario-andreschak/factored-hackathon-2026-mcg/blob/843da50698b559dc748bea4505d1d93483ff29b3/docs/submission/RELEASE_CANDIDATE.md</a:t>
-            </a:r>
-          </a:p>
-          <a:p>
-            <a:r>
-              <a:t>C:\Users\Moe\Documents\GitHub\FLUJO\docs\features\models\connecting.md</a:t>
-            </a:r>
-          </a:p>
-          <a:p>
-            <a:r>
-              <a:t>C:\Users\Moe\Documents\GitHub\FLUJO\docs\statistics.md</a:t>
-            </a:r>
-          </a:p>
-          <a:p>
-            <a:r>
-              <a:t>C:\Users\Moe\Documents\GitHub\factored-hackathon-2026\docs\architecture\rc-runtime-reference.md</a:t>
             </a:r>
           </a:p>
         </p:txBody>
@@ -1037,18 +1097,18 @@
           <a:lstStyle/>
           <a:p>
             <a:r>
-              <a:t>NARRATION (participant voice)</a:t>
-            </a:r>
-          </a:p>
-          <a:p>
-            <a:r>
-              <a:t>For customers, the ambition is less chasing and less repeating. For the bank, it is clearer evidence and a better prepared handoff. Start with transaction disputes, then reuse the same modular service for other customer problems. We are seeking a bank partner for a bounded pilot: measure repeat contacts, helpful answers, handoff quality and cost per case. Ask once. Savia follows through.</a:t>
+              <a:t>SAY (participant voice)</a:t>
+            </a:r>
+          </a:p>
+          <a:p>
+            <a:r>
+              <a:t>For customers, the ambition is less chasing and less repeating. For the bank, it is clearer evidence and a better prepared handoff. Start with transaction disputes, then reuse the same modular service for other customer problems. We are seeking a bank partner for a bounded pilot: measure repeat contacts, helpful answers, handoff quality and cost per case. Measure the service on real customer needs, with a small rollout and a clear review gate. Ask once. Savia follows through.</a:t>
             </a:r>
           </a:p>
           <a:p/>
           <a:p>
             <a:r>
-              <a:t>EVIDENCE / Q&amp;A</a:t>
+              <a:t>IF ASKED</a:t>
             </a:r>
           </a:p>
           <a:p>
@@ -1064,7 +1124,7 @@
           </a:p>
           <a:p>
             <a:r>
-              <a:t>https://github.com/mario-andreschak/factored-hackathon-2026-mcg/blob/95e2b9d62685f2669473258b88935a43dbe1bf75/docs/submission/CUSTOMER_JOURNEY.md</a:t>
+              <a:t>https://github.com/mario-andreschak/factored-hackathon-2026-mcg/blob/7de0bbd670c25e4ad83476c6d7b70c45cc58a137/docs/submission/CUSTOMER_JOURNEY.md</a:t>
             </a:r>
           </a:p>
           <a:p>
@@ -4199,7 +4259,7 @@
                 </a:solidFill>
                 <a:latin typeface="Aptos"/>
               </a:rPr>
-              <a:t>SAVIA  /  ONE VOICE. A NETWORK BEHIND IT.</a:t>
+              <a:t>SAVIA  /  ASK ONCE. SAVIA FOLLOWS THROUGH.</a:t>
             </a:r>
           </a:p>
         </p:txBody>
@@ -4348,7 +4408,7 @@
                 </a:solidFill>
                 <a:latin typeface="Aptos"/>
               </a:rPr>
-              <a:t>A network designed for up to 100 agents on your case.</a:t>
+              <a:t>A case that keeps its context.</a:t>
             </a:r>
           </a:p>
         </p:txBody>
@@ -5370,7 +5430,7 @@
                 </a:solidFill>
                 <a:latin typeface="Aptos"/>
               </a:rPr>
-              <a:t>Product vision.</a:t>
+              <a:t>Checked facts.</a:t>
             </a:r>
           </a:p>
           <a:p>
@@ -5386,7 +5446,7 @@
                 </a:solidFill>
                 <a:latin typeface="Aptos"/>
               </a:rPr>
-              <a:t>Working prototype.</a:t>
+              <a:t>A saved next step.</a:t>
             </a:r>
           </a:p>
         </p:txBody>
@@ -5533,7 +5593,7 @@
                 </a:solidFill>
                 <a:latin typeface="Aptos"/>
               </a:rPr>
-              <a:t>SAVIA  /  ONE VOICE. A NETWORK BEHIND IT.</a:t>
+              <a:t>SAVIA  /  ASK ONCE. SAVIA FOLLOWS THROUGH.</a:t>
             </a:r>
           </a:p>
         </p:txBody>
@@ -5783,7 +5843,7 @@
                 </a:solidFill>
                 <a:latin typeface="Aptos"/>
               </a:rPr>
-              <a:t>Ask</a:t>
+              <a:t>Check</a:t>
             </a:r>
           </a:p>
         </p:txBody>
@@ -5822,7 +5882,7 @@
                 </a:solidFill>
                 <a:latin typeface="Aptos"/>
               </a:rPr>
-              <a:t>One assistant hears your story.</a:t>
+              <a:t>Understand your selected charge.</a:t>
             </a:r>
           </a:p>
         </p:txBody>
@@ -5978,7 +6038,7 @@
                 </a:solidFill>
                 <a:latin typeface="Aptos"/>
               </a:rPr>
-              <a:t>Act</a:t>
+              <a:t>Protect</a:t>
             </a:r>
           </a:p>
         </p:txBody>
@@ -6017,7 +6077,7 @@
                 </a:solidFill>
                 <a:latin typeface="Aptos"/>
               </a:rPr>
-              <a:t>Permitted steps, with consent.</a:t>
+              <a:t>Confirm once. Block your owned card.</a:t>
             </a:r>
           </a:p>
         </p:txBody>
@@ -6173,7 +6233,7 @@
                 </a:solidFill>
                 <a:latin typeface="Aptos"/>
               </a:rPr>
-              <a:t>Investigate</a:t>
+              <a:t>Explore</a:t>
             </a:r>
           </a:p>
         </p:txBody>
@@ -6212,7 +6272,7 @@
                 </a:solidFill>
                 <a:latin typeface="Aptos"/>
               </a:rPr>
-              <a:t>Specialists compare evidence.</a:t>
+              <a:t>Specialists compare the evidence.</a:t>
             </a:r>
           </a:p>
         </p:txBody>
@@ -6372,7 +6432,7 @@
                 </a:solidFill>
                 <a:latin typeface="Aptos"/>
               </a:rPr>
-              <a:t>A result or a human handoff.</a:t>
+              <a:t>Read your saved answer and next step.</a:t>
             </a:r>
           </a:p>
         </p:txBody>
@@ -6456,7 +6516,7 @@
                 </a:solidFill>
                 <a:latin typeface="Aptos"/>
               </a:rPr>
-              <a:t>DEMONSTRATED IN THE PROTOTYPE</a:t>
+              <a:t>CARD PROTECTION / COMPLETED ACTION</a:t>
             </a:r>
           </a:p>
         </p:txBody>
@@ -6469,8 +6529,8 @@
         </p:nvSpPr>
         <p:spPr>
           <a:xfrm>
-            <a:off x="932688" y="6227064"/>
-            <a:ext cx="8915400" cy="566928"/>
+            <a:off x="932688" y="6190488"/>
+            <a:ext cx="8915400" cy="896112"/>
           </a:xfrm>
           <a:prstGeom prst="rect">
             <a:avLst/>
@@ -6489,29 +6549,13 @@
               </a:spcAft>
             </a:pPr>
             <a:r>
-              <a:rPr sz="1800" b="0">
+              <a:rPr sz="1600" b="0">
                 <a:solidFill>
                   <a:srgbClr val="F8F8F2"/>
                 </a:solidFill>
                 <a:latin typeface="Aptos"/>
               </a:rPr>
-              <a:t>Grounded answer · two saved perspectives</a:t>
-            </a:r>
-          </a:p>
-          <a:p>
-            <a:pPr>
-              <a:spcAft>
-                <a:spcPts val="200"/>
-              </a:spcAft>
-            </a:pPr>
-            <a:r>
-              <a:rPr sz="1800" b="0">
-                <a:solidFill>
-                  <a:srgbClr val="F8F8F2"/>
-                </a:solidFill>
-                <a:latin typeface="Aptos"/>
-              </a:rPr>
-              <a:t>Return after a new chat without starting over</a:t>
+              <a:t>Confirm once. Savia blocks the owned card, writes a durable status, and rereads an independent receipt. Asking never writes. Foreign cards, missing consent, and tampered receipts are refused.</a:t>
             </a:r>
           </a:p>
         </p:txBody>
@@ -6613,7 +6657,7 @@
                 </a:solidFill>
                 <a:latin typeface="Aptos"/>
               </a:rPr>
-              <a:t>Product journey shown above; human pickup and bank resolution are pilot integrations. Fictional UI capture.</a:t>
+              <a:t>Demo ledger. Same admission rules a production host would use.</a:t>
             </a:r>
           </a:p>
         </p:txBody>
@@ -6760,7 +6804,7 @@
                 </a:solidFill>
                 <a:latin typeface="Aptos"/>
               </a:rPr>
-              <a:t>SAVIA  /  ONE VOICE. A NETWORK BEHIND IT.</a:t>
+              <a:t>SAVIA  /  ASK ONCE. SAVIA FOLLOWS THROUGH.</a:t>
             </a:r>
           </a:p>
         </p:txBody>
@@ -7132,7 +7176,7 @@
                 </a:solidFill>
                 <a:latin typeface="Aptos"/>
               </a:rPr>
-              <a:t>SAVIA / CASE ORCHESTRATION</a:t>
+              <a:t>SAVIA / THE CONTINUING CASE</a:t>
             </a:r>
           </a:p>
         </p:txBody>
@@ -7210,7 +7254,7 @@
                 </a:solidFill>
                 <a:latin typeface="Aptos"/>
               </a:rPr>
-              <a:t>Persistent goal and saved context</a:t>
+              <a:t>Checked facts and ordered decisions</a:t>
             </a:r>
           </a:p>
           <a:p>
@@ -7226,7 +7270,7 @@
                 </a:solidFill>
                 <a:latin typeface="Aptos"/>
               </a:rPr>
-              <a:t>Up to 100 agents in the swarm design</a:t>
+              <a:t>Explicit consent and saved receipts</a:t>
             </a:r>
           </a:p>
           <a:p>
@@ -7242,7 +7286,7 @@
                 </a:solidFill>
                 <a:latin typeface="Aptos"/>
               </a:rPr>
-              <a:t>Bank-controlled data and model choices</a:t>
+              <a:t>Saved context and specialist perspectives</a:t>
             </a:r>
           </a:p>
         </p:txBody>
@@ -7281,7 +7325,7 @@
                 </a:solidFill>
                 <a:latin typeface="Aptos"/>
               </a:rPr>
-              <a:t>A familiar voice. A persistent case. A network you control.</a:t>
+              <a:t>A familiar voice. A persistent case. A clear next step.</a:t>
             </a:r>
           </a:p>
         </p:txBody>
@@ -7314,13 +7358,13 @@
               </a:spcAft>
             </a:pPr>
             <a:r>
-              <a:rPr sz="1000" b="0">
+              <a:rPr sz="1200" b="0">
                 <a:solidFill>
                   <a:srgbClr val="C6D3CA"/>
                 </a:solidFill>
                 <a:latin typeface="Aptos"/>
               </a:rPr>
-              <a:t>Comparison of product emphasis; no head-to-head benchmark or claim of exclusive capabilities.</a:t>
+              <a:t>Two people. Ten days. A service the bank can inspect and control.</a:t>
             </a:r>
           </a:p>
         </p:txBody>
@@ -7469,7 +7513,7 @@
                 </a:solidFill>
                 <a:latin typeface="Aptos"/>
               </a:rPr>
-              <a:t>03 / THE AI SWARM</a:t>
+              <a:t>03 / THE SWARM DESIGN</a:t>
             </a:r>
           </a:p>
         </p:txBody>
@@ -7508,7 +7552,7 @@
                 </a:solidFill>
                 <a:latin typeface="Aptos"/>
               </a:rPr>
-              <a:t>SAVIA  /  ONE VOICE. A NETWORK BEHIND IT.</a:t>
+              <a:t>SAVIA  /  ASK ONCE. SAVIA FOLLOWS THROUGH.</a:t>
             </a:r>
           </a:p>
         </p:txBody>
@@ -7586,7 +7630,7 @@
                 </a:solidFill>
                 <a:latin typeface="Aptos"/>
               </a:rPr>
-              <a:t>One conversation.</a:t>
+              <a:t>One customer voice.</a:t>
             </a:r>
           </a:p>
           <a:p>
@@ -7602,7 +7646,7 @@
                 </a:solidFill>
                 <a:latin typeface="Aptos"/>
               </a:rPr>
-              <a:t>Up to 100 agents behind it.</a:t>
+              <a:t>Ten teams behind it.</a:t>
             </a:r>
           </a:p>
         </p:txBody>
@@ -7719,7 +7763,7 @@
                 </a:solidFill>
                 <a:latin typeface="Aptos"/>
               </a:rPr>
-              <a:t>10 teams × (1 lead + 9 specialists)</a:t>
+              <a:t>SWARM DESIGN</a:t>
             </a:r>
           </a:p>
           <a:p>
@@ -7735,7 +7779,7 @@
                 </a:solidFill>
                 <a:latin typeface="Aptos"/>
               </a:rPr>
-              <a:t>Savia’s coordinator is separate.</a:t>
+              <a:t>10 teams × (1 lead + 9 specialists)</a:t>
             </a:r>
           </a:p>
         </p:txBody>
@@ -12914,7 +12958,7 @@
                 </a:solidFill>
                 <a:latin typeface="Aptos"/>
               </a:rPr>
-              <a:t>LEAD + SPECIALISTS  /  SHARED EVIDENCE  /  INDEPENDENT REVIEW</a:t>
+              <a:t>SHARED EVIDENCE  /  SPECIALIST COLLABORATION  /  INDEPENDENT REVIEW</a:t>
             </a:r>
           </a:p>
         </p:txBody>
@@ -12998,7 +13042,7 @@
                 </a:solidFill>
                 <a:latin typeface="Aptos"/>
               </a:rPr>
-              <a:t>Communicate</a:t>
+              <a:t>300 / 300</a:t>
             </a:r>
           </a:p>
         </p:txBody>
@@ -13037,7 +13081,7 @@
                 </a:solidFill>
                 <a:latin typeface="Aptos"/>
               </a:rPr>
-              <a:t>Native messages + fleet relay</a:t>
+              <a:t>Concurrent FLUJO reference returns</a:t>
             </a:r>
           </a:p>
         </p:txBody>
@@ -13121,7 +13165,7 @@
                 </a:solidFill>
                 <a:latin typeface="Aptos"/>
               </a:rPr>
-              <a:t>Challenge</a:t>
+              <a:t>18 live together</a:t>
             </a:r>
           </a:p>
         </p:txBody>
@@ -13160,7 +13204,7 @@
                 </a:solidFill>
                 <a:latin typeface="Aptos"/>
               </a:rPr>
-              <a:t>Shared board + peer review</a:t>
+              <a:t>Sandboxes in the tested foundation</a:t>
             </a:r>
           </a:p>
         </p:txBody>
@@ -13244,7 +13288,7 @@
                 </a:solidFill>
                 <a:latin typeface="Aptos"/>
               </a:rPr>
-              <a:t>Recover</a:t>
+              <a:t>Two completed reviewers</a:t>
             </a:r>
           </a:p>
         </p:txBody>
@@ -13283,7 +13327,7 @@
                 </a:solidFill>
                 <a:latin typeface="Aptos"/>
               </a:rPr>
-              <a:t>Saved context; hold uncertain retries</a:t>
+              <a:t>The customer path we recorded</a:t>
             </a:r>
           </a:p>
         </p:txBody>
@@ -13316,13 +13360,13 @@
               </a:spcAft>
             </a:pPr>
             <a:r>
-              <a:rPr sz="1100" b="0">
+              <a:rPr sz="1200" b="0">
                 <a:solidFill>
-                  <a:srgbClr val="E9C977"/>
+                  <a:srgbClr val="D9EDB7"/>
                 </a:solidFill>
                 <a:latin typeface="Aptos"/>
               </a:rPr>
-              <a:t>Swarm design and deployed connector. Exact 100-agent customer completion remains to be qualified.</a:t>
+              <a:t>One customer voice. Ten teams behind it. The architecture is ready to scale.</a:t>
             </a:r>
           </a:p>
         </p:txBody>
@@ -13430,7 +13474,7 @@
                 </a:solidFill>
                 <a:latin typeface="Aptos"/>
               </a:rPr>
-              <a:t>04 / DEPLOYMENT, DATA &amp; PROOF</a:t>
+              <a:t>04 / QUALIFIED PROOF &amp; DATA DECISIONS</a:t>
             </a:r>
           </a:p>
         </p:txBody>
@@ -13469,7 +13513,7 @@
                 </a:solidFill>
                 <a:latin typeface="Aptos"/>
               </a:rPr>
-              <a:t>SAVIA  /  ONE VOICE. A NETWORK BEHIND IT.</a:t>
+              <a:t>SAVIA  /  ASK ONCE. SAVIA FOLLOWS THROUGH.</a:t>
             </a:r>
           </a:p>
         </p:txBody>
@@ -13547,7 +13591,7 @@
                 </a:solidFill>
                 <a:latin typeface="Aptos"/>
               </a:rPr>
-              <a:t>The bank controls the stack.</a:t>
+              <a:t>Evidence you can inspect.</a:t>
             </a:r>
           </a:p>
           <a:p>
@@ -13563,21 +13607,60 @@
                 </a:solidFill>
                 <a:latin typeface="Aptos"/>
               </a:rPr>
-              <a:t>The work leaves a trace.</a:t>
-            </a:r>
-          </a:p>
-        </p:txBody>
-      </p:sp>
-      <p:sp>
-        <p:nvSpPr>
-          <p:cNvPr id="7" name="Rounded Rectangle 6"/>
+              <a:t>Choices a bank can control.</a:t>
+            </a:r>
+          </a:p>
+        </p:txBody>
+      </p:sp>
+      <p:sp>
+        <p:nvSpPr>
+          <p:cNvPr id="7" name="TextBox 6"/>
+          <p:cNvSpPr txBox="1"/>
+          <p:nvPr/>
+        </p:nvSpPr>
+        <p:spPr>
+          <a:xfrm>
+            <a:off x="749808" y="2651760"/>
+            <a:ext cx="13075920" cy="365760"/>
+          </a:xfrm>
+          <a:prstGeom prst="rect">
+            <a:avLst/>
+          </a:prstGeom>
+          <a:noFill/>
+        </p:spPr>
+        <p:txBody>
+          <a:bodyPr wrap="square" lIns="9144" rIns="9144" tIns="0" bIns="0" anchor="t">
+            <a:spAutoFit/>
+          </a:bodyPr>
+          <a:lstStyle/>
+          <a:p>
+            <a:pPr>
+              <a:spcAft>
+                <a:spcPts val="200"/>
+              </a:spcAft>
+            </a:pPr>
+            <a:r>
+              <a:rPr sz="2200" b="1">
+                <a:solidFill>
+                  <a:srgbClr val="D9EDB7"/>
+                </a:solidFill>
+                <a:latin typeface="Aptos"/>
+              </a:rPr>
+              <a:t>Policy, not the model, authorizes the card action.</a:t>
+            </a:r>
+          </a:p>
+        </p:txBody>
+      </p:sp>
+      <p:sp>
+        <p:nvSpPr>
+          <p:cNvPr id="8" name="Rounded Rectangle 7"/>
           <p:cNvSpPr/>
           <p:nvPr/>
         </p:nvSpPr>
         <p:spPr>
           <a:xfrm>
-            <a:off x="731520" y="2688336"/>
-            <a:ext cx="3090672" cy="1234440"/>
+            <a:off x="731520" y="3218688"/>
+            <a:ext cx="3090672" cy="859536"/>
           </a:xfrm>
           <a:prstGeom prst="roundRect">
             <a:avLst>
@@ -13615,14 +13698,14 @@
       </p:sp>
       <p:sp>
         <p:nvSpPr>
-          <p:cNvPr id="8" name="TextBox 7"/>
+          <p:cNvPr id="9" name="TextBox 8"/>
           <p:cNvSpPr txBox="1"/>
           <p:nvPr/>
         </p:nvSpPr>
         <p:spPr>
           <a:xfrm>
-            <a:off x="905256" y="2871216"/>
-            <a:ext cx="2724912" cy="265176"/>
+            <a:off x="877824" y="3355848"/>
+            <a:ext cx="2788920" cy="210312"/>
           </a:xfrm>
           <a:prstGeom prst="rect">
             <a:avLst/>
@@ -13641,27 +13724,27 @@
               </a:spcAft>
             </a:pPr>
             <a:r>
-              <a:rPr sz="1000" b="1">
+              <a:rPr sz="900" b="1">
                 <a:solidFill>
                   <a:srgbClr val="D9EDB7"/>
                 </a:solidFill>
                 <a:latin typeface="Aptos"/>
               </a:rPr>
-              <a:t>CUSTOMER</a:t>
-            </a:r>
-          </a:p>
-        </p:txBody>
-      </p:sp>
-      <p:sp>
-        <p:nvSpPr>
-          <p:cNvPr id="9" name="TextBox 8"/>
+              <a:t>OWNED FACTS</a:t>
+            </a:r>
+          </a:p>
+        </p:txBody>
+      </p:sp>
+      <p:sp>
+        <p:nvSpPr>
+          <p:cNvPr id="10" name="TextBox 9"/>
           <p:cNvSpPr txBox="1"/>
           <p:nvPr/>
         </p:nvSpPr>
         <p:spPr>
           <a:xfrm>
-            <a:off x="905256" y="3364992"/>
-            <a:ext cx="2743200" cy="393192"/>
+            <a:off x="877824" y="3703320"/>
+            <a:ext cx="2788920" cy="265176"/>
           </a:xfrm>
           <a:prstGeom prst="rect">
             <a:avLst/>
@@ -13680,27 +13763,27 @@
               </a:spcAft>
             </a:pPr>
             <a:r>
-              <a:rPr sz="2000" b="1">
+              <a:rPr sz="1600" b="1">
                 <a:solidFill>
                   <a:srgbClr val="F8F8F2"/>
                 </a:solidFill>
                 <a:latin typeface="Aptos"/>
               </a:rPr>
-              <a:t>Voice + text</a:t>
-            </a:r>
-          </a:p>
-        </p:txBody>
-      </p:sp>
-      <p:sp>
-        <p:nvSpPr>
-          <p:cNvPr id="10" name="TextBox 9"/>
+              <a:t>Customer + charge</a:t>
+            </a:r>
+          </a:p>
+        </p:txBody>
+      </p:sp>
+      <p:sp>
+        <p:nvSpPr>
+          <p:cNvPr id="11" name="TextBox 10"/>
           <p:cNvSpPr txBox="1"/>
           <p:nvPr/>
         </p:nvSpPr>
         <p:spPr>
           <a:xfrm>
-            <a:off x="3831336" y="3145536"/>
-            <a:ext cx="228600" cy="457200"/>
+            <a:off x="3831336" y="3557016"/>
+            <a:ext cx="228600" cy="292608"/>
           </a:xfrm>
           <a:prstGeom prst="rect">
             <a:avLst/>
@@ -13719,7 +13802,7 @@
               </a:spcAft>
             </a:pPr>
             <a:r>
-              <a:rPr sz="1600" b="1">
+              <a:rPr sz="1400" b="1">
                 <a:solidFill>
                   <a:srgbClr val="D9EDB7"/>
                 </a:solidFill>
@@ -13732,14 +13815,14 @@
       </p:sp>
       <p:sp>
         <p:nvSpPr>
-          <p:cNvPr id="11" name="Rounded Rectangle 10"/>
+          <p:cNvPr id="12" name="Rounded Rectangle 11"/>
           <p:cNvSpPr/>
           <p:nvPr/>
         </p:nvSpPr>
         <p:spPr>
           <a:xfrm>
-            <a:off x="4069080" y="2688336"/>
-            <a:ext cx="3090672" cy="1234440"/>
+            <a:off x="4069080" y="3218688"/>
+            <a:ext cx="3090672" cy="859536"/>
           </a:xfrm>
           <a:prstGeom prst="roundRect">
             <a:avLst>
@@ -13777,14 +13860,14 @@
       </p:sp>
       <p:sp>
         <p:nvSpPr>
-          <p:cNvPr id="12" name="TextBox 11"/>
+          <p:cNvPr id="13" name="TextBox 12"/>
           <p:cNvSpPr txBox="1"/>
           <p:nvPr/>
         </p:nvSpPr>
         <p:spPr>
           <a:xfrm>
-            <a:off x="4242816" y="2871216"/>
-            <a:ext cx="2724912" cy="265176"/>
+            <a:off x="4215384" y="3355848"/>
+            <a:ext cx="2788920" cy="210312"/>
           </a:xfrm>
           <a:prstGeom prst="rect">
             <a:avLst/>
@@ -13803,27 +13886,27 @@
               </a:spcAft>
             </a:pPr>
             <a:r>
-              <a:rPr sz="1000" b="1">
+              <a:rPr sz="900" b="1">
                 <a:solidFill>
                   <a:srgbClr val="D9EDB7"/>
                 </a:solidFill>
                 <a:latin typeface="Aptos"/>
               </a:rPr>
-              <a:t>SAVIA HOST</a:t>
-            </a:r>
-          </a:p>
-        </p:txBody>
-      </p:sp>
-      <p:sp>
-        <p:nvSpPr>
-          <p:cNvPr id="13" name="TextBox 12"/>
+              <a:t>ORDERED POLICY</a:t>
+            </a:r>
+          </a:p>
+        </p:txBody>
+      </p:sp>
+      <p:sp>
+        <p:nvSpPr>
+          <p:cNvPr id="14" name="TextBox 13"/>
           <p:cNvSpPr txBox="1"/>
           <p:nvPr/>
         </p:nvSpPr>
         <p:spPr>
           <a:xfrm>
-            <a:off x="4242816" y="3364992"/>
-            <a:ext cx="2743200" cy="393192"/>
+            <a:off x="4215384" y="3703320"/>
+            <a:ext cx="2788920" cy="265176"/>
           </a:xfrm>
           <a:prstGeom prst="rect">
             <a:avLst/>
@@ -13842,27 +13925,27 @@
               </a:spcAft>
             </a:pPr>
             <a:r>
-              <a:rPr sz="2000" b="1">
+              <a:rPr sz="1600" b="1">
                 <a:solidFill>
                   <a:srgbClr val="F8F8F2"/>
                 </a:solidFill>
                 <a:latin typeface="Aptos"/>
               </a:rPr>
-              <a:t>Case + consent</a:t>
-            </a:r>
-          </a:p>
-        </p:txBody>
-      </p:sp>
-      <p:sp>
-        <p:nvSpPr>
-          <p:cNvPr id="14" name="TextBox 13"/>
+              <a:t>R0–R18 + consent</a:t>
+            </a:r>
+          </a:p>
+        </p:txBody>
+      </p:sp>
+      <p:sp>
+        <p:nvSpPr>
+          <p:cNvPr id="15" name="TextBox 14"/>
           <p:cNvSpPr txBox="1"/>
           <p:nvPr/>
         </p:nvSpPr>
         <p:spPr>
           <a:xfrm>
-            <a:off x="7168896" y="3145536"/>
-            <a:ext cx="228600" cy="457200"/>
+            <a:off x="7168896" y="3557016"/>
+            <a:ext cx="228600" cy="292608"/>
           </a:xfrm>
           <a:prstGeom prst="rect">
             <a:avLst/>
@@ -13881,7 +13964,7 @@
               </a:spcAft>
             </a:pPr>
             <a:r>
-              <a:rPr sz="1600" b="1">
+              <a:rPr sz="1400" b="1">
                 <a:solidFill>
                   <a:srgbClr val="D9EDB7"/>
                 </a:solidFill>
@@ -13894,14 +13977,14 @@
       </p:sp>
       <p:sp>
         <p:nvSpPr>
-          <p:cNvPr id="15" name="Rounded Rectangle 14"/>
+          <p:cNvPr id="16" name="Rounded Rectangle 15"/>
           <p:cNvSpPr/>
           <p:nvPr/>
         </p:nvSpPr>
         <p:spPr>
           <a:xfrm>
-            <a:off x="7406640" y="2688336"/>
-            <a:ext cx="3090672" cy="1234440"/>
+            <a:off x="7406640" y="3218688"/>
+            <a:ext cx="3090672" cy="859536"/>
           </a:xfrm>
           <a:prstGeom prst="roundRect">
             <a:avLst>
@@ -13939,14 +14022,14 @@
       </p:sp>
       <p:sp>
         <p:nvSpPr>
-          <p:cNvPr id="16" name="TextBox 15"/>
+          <p:cNvPr id="17" name="TextBox 16"/>
           <p:cNvSpPr txBox="1"/>
           <p:nvPr/>
         </p:nvSpPr>
         <p:spPr>
           <a:xfrm>
-            <a:off x="7580375" y="2871216"/>
-            <a:ext cx="2724912" cy="265176"/>
+            <a:off x="7552944" y="3355848"/>
+            <a:ext cx="2788920" cy="210312"/>
           </a:xfrm>
           <a:prstGeom prst="rect">
             <a:avLst/>
@@ -13965,27 +14048,27 @@
               </a:spcAft>
             </a:pPr>
             <a:r>
-              <a:rPr sz="1000" b="1">
+              <a:rPr sz="900" b="1">
                 <a:solidFill>
                   <a:srgbClr val="D9EDB7"/>
                 </a:solidFill>
                 <a:latin typeface="Aptos"/>
               </a:rPr>
-              <a:t>FLUJO</a:t>
-            </a:r>
-          </a:p>
-        </p:txBody>
-      </p:sp>
-      <p:sp>
-        <p:nvSpPr>
-          <p:cNvPr id="17" name="TextBox 16"/>
+              <a:t>VERIFIED RECEIPT</a:t>
+            </a:r>
+          </a:p>
+        </p:txBody>
+      </p:sp>
+      <p:sp>
+        <p:nvSpPr>
+          <p:cNvPr id="18" name="TextBox 17"/>
           <p:cNvSpPr txBox="1"/>
           <p:nvPr/>
         </p:nvSpPr>
         <p:spPr>
           <a:xfrm>
-            <a:off x="7580375" y="3364992"/>
-            <a:ext cx="2743200" cy="393192"/>
+            <a:off x="7552944" y="3703320"/>
+            <a:ext cx="2788920" cy="265176"/>
           </a:xfrm>
           <a:prstGeom prst="rect">
             <a:avLst/>
@@ -14004,27 +14087,27 @@
               </a:spcAft>
             </a:pPr>
             <a:r>
-              <a:rPr sz="2000" b="1">
+              <a:rPr sz="1600" b="1">
                 <a:solidFill>
                   <a:srgbClr val="F8F8F2"/>
                 </a:solidFill>
                 <a:latin typeface="Aptos"/>
               </a:rPr>
-              <a:t>Agents + statistics</a:t>
-            </a:r>
-          </a:p>
-        </p:txBody>
-      </p:sp>
-      <p:sp>
-        <p:nvSpPr>
-          <p:cNvPr id="18" name="TextBox 17"/>
+              <a:t>Readback + recovery</a:t>
+            </a:r>
+          </a:p>
+        </p:txBody>
+      </p:sp>
+      <p:sp>
+        <p:nvSpPr>
+          <p:cNvPr id="19" name="TextBox 18"/>
           <p:cNvSpPr txBox="1"/>
           <p:nvPr/>
         </p:nvSpPr>
         <p:spPr>
           <a:xfrm>
-            <a:off x="10506456" y="3145536"/>
-            <a:ext cx="228600" cy="457200"/>
+            <a:off x="10506456" y="3557016"/>
+            <a:ext cx="228600" cy="292608"/>
           </a:xfrm>
           <a:prstGeom prst="rect">
             <a:avLst/>
@@ -14043,7 +14126,7 @@
               </a:spcAft>
             </a:pPr>
             <a:r>
-              <a:rPr sz="1600" b="1">
+              <a:rPr sz="1400" b="1">
                 <a:solidFill>
                   <a:srgbClr val="D9EDB7"/>
                 </a:solidFill>
@@ -14056,14 +14139,14 @@
       </p:sp>
       <p:sp>
         <p:nvSpPr>
-          <p:cNvPr id="19" name="Rounded Rectangle 18"/>
+          <p:cNvPr id="20" name="Rounded Rectangle 19"/>
           <p:cNvSpPr/>
           <p:nvPr/>
         </p:nvSpPr>
         <p:spPr>
           <a:xfrm>
-            <a:off x="10744200" y="2688336"/>
-            <a:ext cx="3090672" cy="1234440"/>
+            <a:off x="10744200" y="3218688"/>
+            <a:ext cx="3090672" cy="859536"/>
           </a:xfrm>
           <a:prstGeom prst="roundRect">
             <a:avLst>
@@ -14101,14 +14184,14 @@
       </p:sp>
       <p:sp>
         <p:nvSpPr>
-          <p:cNvPr id="20" name="TextBox 19"/>
+          <p:cNvPr id="21" name="TextBox 20"/>
           <p:cNvSpPr txBox="1"/>
           <p:nvPr/>
         </p:nvSpPr>
         <p:spPr>
           <a:xfrm>
-            <a:off x="10917936" y="2871216"/>
-            <a:ext cx="2724912" cy="265176"/>
+            <a:off x="10890504" y="3355848"/>
+            <a:ext cx="2788920" cy="210312"/>
           </a:xfrm>
           <a:prstGeom prst="rect">
             <a:avLst/>
@@ -14127,27 +14210,27 @@
               </a:spcAft>
             </a:pPr>
             <a:r>
-              <a:rPr sz="1000" b="1">
+              <a:rPr sz="900" b="1">
                 <a:solidFill>
                   <a:srgbClr val="D9EDB7"/>
                 </a:solidFill>
                 <a:latin typeface="Aptos"/>
               </a:rPr>
-              <a:t>BANKING MCP</a:t>
-            </a:r>
-          </a:p>
-        </p:txBody>
-      </p:sp>
-      <p:sp>
-        <p:nvSpPr>
-          <p:cNvPr id="21" name="TextBox 20"/>
+              <a:t>SAVED FOLLOW-UP</a:t>
+            </a:r>
+          </a:p>
+        </p:txBody>
+      </p:sp>
+      <p:sp>
+        <p:nvSpPr>
+          <p:cNvPr id="22" name="TextBox 21"/>
           <p:cNvSpPr txBox="1"/>
           <p:nvPr/>
         </p:nvSpPr>
         <p:spPr>
           <a:xfrm>
-            <a:off x="10917936" y="3364992"/>
-            <a:ext cx="2743200" cy="393192"/>
+            <a:off x="10890504" y="3703320"/>
+            <a:ext cx="2788920" cy="265176"/>
           </a:xfrm>
           <a:prstGeom prst="rect">
             <a:avLst/>
@@ -14166,27 +14249,72 @@
               </a:spcAft>
             </a:pPr>
             <a:r>
-              <a:rPr sz="2000" b="1">
+              <a:rPr sz="1600" b="1">
                 <a:solidFill>
                   <a:srgbClr val="F8F8F2"/>
                 </a:solidFill>
                 <a:latin typeface="Aptos"/>
               </a:rPr>
-              <a:t>Scoped data + tools</a:t>
-            </a:r>
-          </a:p>
-        </p:txBody>
-      </p:sp>
-      <p:sp>
-        <p:nvSpPr>
-          <p:cNvPr id="22" name="TextBox 21"/>
+              <a:t>Context + handoff</a:t>
+            </a:r>
+          </a:p>
+        </p:txBody>
+      </p:sp>
+      <p:sp>
+        <p:nvSpPr>
+          <p:cNvPr id="23" name="Rounded Rectangle 22"/>
+          <p:cNvSpPr/>
+          <p:nvPr/>
+        </p:nvSpPr>
+        <p:spPr>
+          <a:xfrm>
+            <a:off x="731520" y="4325112"/>
+            <a:ext cx="4206240" cy="1755648"/>
+          </a:xfrm>
+          <a:prstGeom prst="roundRect">
+            <a:avLst>
+              <a:gd name="adj" fmla="val 12000"/>
+            </a:avLst>
+          </a:prstGeom>
+          <a:solidFill>
+            <a:srgbClr val="214A3F"/>
+          </a:solidFill>
+          <a:ln>
+            <a:noFill/>
+          </a:ln>
+        </p:spPr>
+        <p:style>
+          <a:lnRef idx="1">
+            <a:schemeClr val="accent1"/>
+          </a:lnRef>
+          <a:fillRef idx="3">
+            <a:schemeClr val="accent1"/>
+          </a:fillRef>
+          <a:effectRef idx="2">
+            <a:schemeClr val="accent1"/>
+          </a:effectRef>
+          <a:fontRef idx="minor">
+            <a:schemeClr val="lt1"/>
+          </a:fontRef>
+        </p:style>
+        <p:txBody>
+          <a:bodyPr rtlCol="0" anchor="ctr"/>
+          <a:lstStyle/>
+          <a:p>
+            <a:pPr algn="ctr"/>
+          </a:p>
+        </p:txBody>
+      </p:sp>
+      <p:sp>
+        <p:nvSpPr>
+          <p:cNvPr id="24" name="TextBox 23"/>
           <p:cNvSpPr txBox="1"/>
           <p:nvPr/>
         </p:nvSpPr>
         <p:spPr>
           <a:xfrm>
-            <a:off x="777240" y="4133087"/>
-            <a:ext cx="13167360" cy="283464"/>
+            <a:off x="905256" y="4471416"/>
+            <a:ext cx="3849624" cy="530352"/>
           </a:xfrm>
           <a:prstGeom prst="rect">
             <a:avLst/>
@@ -14205,98 +14333,14 @@
               </a:spcAft>
             </a:pPr>
             <a:r>
-              <a:rPr sz="1600" b="0">
-                <a:solidFill>
-                  <a:srgbClr val="C6D3CA"/>
-                </a:solidFill>
-                <a:latin typeface="Aptos"/>
-              </a:rPr>
-              <a:t>TLS ingress · separated data and state · authority stays in Savia + Banking MCP</a:t>
-            </a:r>
-          </a:p>
-        </p:txBody>
-      </p:sp>
-      <p:sp>
-        <p:nvSpPr>
-          <p:cNvPr id="23" name="TextBox 22"/>
-          <p:cNvSpPr txBox="1"/>
-          <p:nvPr/>
-        </p:nvSpPr>
-        <p:spPr>
-          <a:xfrm>
-            <a:off x="777240" y="4663440"/>
-            <a:ext cx="13167360" cy="329184"/>
-          </a:xfrm>
-          <a:prstGeom prst="rect">
-            <a:avLst/>
-          </a:prstGeom>
-          <a:noFill/>
-        </p:spPr>
-        <p:txBody>
-          <a:bodyPr wrap="square" lIns="9144" rIns="9144" tIns="0" bIns="0" anchor="t">
-            <a:spAutoFit/>
-          </a:bodyPr>
-          <a:lstStyle/>
-          <a:p>
-            <a:pPr>
-              <a:spcAft>
-                <a:spcPts val="200"/>
-              </a:spcAft>
-            </a:pPr>
-            <a:r>
-              <a:rPr sz="1600" b="1">
+              <a:rPr sz="3200" b="1">
                 <a:solidFill>
                   <a:srgbClr val="D9EDB7"/>
                 </a:solidFill>
                 <a:latin typeface="Aptos"/>
               </a:rPr>
-              <a:t>Self-hostable foundation · local open-weight model option · interchangeable MCP / model modules</a:t>
-            </a:r>
-          </a:p>
-        </p:txBody>
-      </p:sp>
-      <p:sp>
-        <p:nvSpPr>
-          <p:cNvPr id="24" name="Rounded Rectangle 23"/>
-          <p:cNvSpPr/>
-          <p:nvPr/>
-        </p:nvSpPr>
-        <p:spPr>
-          <a:xfrm>
-            <a:off x="731520" y="5367528"/>
-            <a:ext cx="4206240" cy="1719072"/>
-          </a:xfrm>
-          <a:prstGeom prst="roundRect">
-            <a:avLst>
-              <a:gd name="adj" fmla="val 12000"/>
-            </a:avLst>
-          </a:prstGeom>
-          <a:solidFill>
-            <a:srgbClr val="214A3F"/>
-          </a:solidFill>
-          <a:ln>
-            <a:noFill/>
-          </a:ln>
-        </p:spPr>
-        <p:style>
-          <a:lnRef idx="1">
-            <a:schemeClr val="accent1"/>
-          </a:lnRef>
-          <a:fillRef idx="3">
-            <a:schemeClr val="accent1"/>
-          </a:fillRef>
-          <a:effectRef idx="2">
-            <a:schemeClr val="accent1"/>
-          </a:effectRef>
-          <a:fontRef idx="minor">
-            <a:schemeClr val="lt1"/>
-          </a:fontRef>
-        </p:style>
-        <p:txBody>
-          <a:bodyPr rtlCol="0" anchor="ctr"/>
-          <a:lstStyle/>
-          <a:p>
-            <a:pPr algn="ctr"/>
+              <a:t>1,078</a:t>
+            </a:r>
           </a:p>
         </p:txBody>
       </p:sp>
@@ -14308,47 +14352,8 @@
         </p:nvSpPr>
         <p:spPr>
           <a:xfrm>
-            <a:off x="905256" y="5541264"/>
-            <a:ext cx="3849624" cy="566928"/>
-          </a:xfrm>
-          <a:prstGeom prst="rect">
-            <a:avLst/>
-          </a:prstGeom>
-          <a:noFill/>
-        </p:spPr>
-        <p:txBody>
-          <a:bodyPr wrap="square" lIns="9144" rIns="9144" tIns="0" bIns="0" anchor="t">
-            <a:spAutoFit/>
-          </a:bodyPr>
-          <a:lstStyle/>
-          <a:p>
-            <a:pPr>
-              <a:spcAft>
-                <a:spcPts val="200"/>
-              </a:spcAft>
-            </a:pPr>
-            <a:r>
-              <a:rPr sz="3000" b="1">
-                <a:solidFill>
-                  <a:srgbClr val="D9EDB7"/>
-                </a:solidFill>
-                <a:latin typeface="Aptos"/>
-              </a:rPr>
-              <a:t>300/300</a:t>
-            </a:r>
-          </a:p>
-        </p:txBody>
-      </p:sp>
-      <p:sp>
-        <p:nvSpPr>
-          <p:cNvPr id="26" name="TextBox 25"/>
-          <p:cNvSpPr txBox="1"/>
-          <p:nvPr/>
-        </p:nvSpPr>
-        <p:spPr>
-          <a:xfrm>
-            <a:off x="905256" y="6181344"/>
-            <a:ext cx="3849624" cy="274320"/>
+            <a:off x="905256" y="5084064"/>
+            <a:ext cx="3849624" cy="256032"/>
           </a:xfrm>
           <a:prstGeom prst="rect">
             <a:avLst/>
@@ -14373,21 +14378,21 @@
                 </a:solidFill>
                 <a:latin typeface="Aptos"/>
               </a:rPr>
-              <a:t>correct FLUJO reference returns</a:t>
-            </a:r>
-          </a:p>
-        </p:txBody>
-      </p:sp>
-      <p:sp>
-        <p:nvSpPr>
-          <p:cNvPr id="27" name="TextBox 26"/>
+              <a:t>offline core checks</a:t>
+            </a:r>
+          </a:p>
+        </p:txBody>
+      </p:sp>
+      <p:sp>
+        <p:nvSpPr>
+          <p:cNvPr id="26" name="TextBox 25"/>
           <p:cNvSpPr txBox="1"/>
           <p:nvPr/>
         </p:nvSpPr>
         <p:spPr>
           <a:xfrm>
-            <a:off x="905256" y="6583680"/>
-            <a:ext cx="3849624" cy="438912"/>
+            <a:off x="905256" y="5477256"/>
+            <a:ext cx="3849624" cy="429768"/>
           </a:xfrm>
           <a:prstGeom prst="rect">
             <a:avLst/>
@@ -14412,7 +14417,7 @@
                 </a:solidFill>
                 <a:latin typeface="Aptos"/>
               </a:rPr>
-              <a:t>300 queued 1k requests; repeat run</a:t>
+              <a:t>R0–R18, ownership, consent,</a:t>
             </a:r>
           </a:p>
           <a:p>
@@ -14428,21 +14433,21 @@
                 </a:solidFill>
                 <a:latin typeface="Aptos"/>
               </a:rPr>
-              <a:t>p50 273 s / p95 442 s</a:t>
-            </a:r>
-          </a:p>
-        </p:txBody>
-      </p:sp>
-      <p:sp>
-        <p:nvSpPr>
-          <p:cNvPr id="28" name="Rounded Rectangle 27"/>
+              <a:t>receipts and recovery</a:t>
+            </a:r>
+          </a:p>
+        </p:txBody>
+      </p:sp>
+      <p:sp>
+        <p:nvSpPr>
+          <p:cNvPr id="27" name="Rounded Rectangle 26"/>
           <p:cNvSpPr/>
           <p:nvPr/>
         </p:nvSpPr>
         <p:spPr>
           <a:xfrm>
-            <a:off x="5157216" y="5367528"/>
-            <a:ext cx="4206240" cy="1719072"/>
+            <a:off x="5157216" y="4325112"/>
+            <a:ext cx="4206240" cy="1755648"/>
           </a:xfrm>
           <a:prstGeom prst="roundRect">
             <a:avLst>
@@ -14480,14 +14485,14 @@
       </p:sp>
       <p:sp>
         <p:nvSpPr>
-          <p:cNvPr id="29" name="TextBox 28"/>
+          <p:cNvPr id="28" name="TextBox 27"/>
           <p:cNvSpPr txBox="1"/>
           <p:nvPr/>
         </p:nvSpPr>
         <p:spPr>
           <a:xfrm>
-            <a:off x="5330952" y="5541264"/>
-            <a:ext cx="3849624" cy="566928"/>
+            <a:off x="5330952" y="4471416"/>
+            <a:ext cx="3849624" cy="530352"/>
           </a:xfrm>
           <a:prstGeom prst="rect">
             <a:avLst/>
@@ -14506,27 +14511,27 @@
               </a:spcAft>
             </a:pPr>
             <a:r>
-              <a:rPr sz="3000" b="1">
+              <a:rPr sz="3200" b="1">
                 <a:solidFill>
                   <a:srgbClr val="D9EDB7"/>
                 </a:solidFill>
                 <a:latin typeface="Aptos"/>
               </a:rPr>
-              <a:t>129 / 367</a:t>
-            </a:r>
-          </a:p>
-        </p:txBody>
-      </p:sp>
-      <p:sp>
-        <p:nvSpPr>
-          <p:cNvPr id="30" name="TextBox 29"/>
+              <a:t>100 / 100</a:t>
+            </a:r>
+          </a:p>
+        </p:txBody>
+      </p:sp>
+      <p:sp>
+        <p:nvSpPr>
+          <p:cNvPr id="29" name="TextBox 28"/>
           <p:cNvSpPr txBox="1"/>
           <p:nvPr/>
         </p:nvSpPr>
         <p:spPr>
           <a:xfrm>
-            <a:off x="5330952" y="6181344"/>
-            <a:ext cx="3849624" cy="274320"/>
+            <a:off x="5330952" y="5084064"/>
+            <a:ext cx="3849624" cy="256032"/>
           </a:xfrm>
           <a:prstGeom prst="rect">
             <a:avLst/>
@@ -14551,21 +14556,21 @@
                 </a:solidFill>
                 <a:latin typeface="Aptos"/>
               </a:rPr>
-              <a:t>frontend / backend tests</a:t>
-            </a:r>
-          </a:p>
-        </p:txBody>
-      </p:sp>
-      <p:sp>
-        <p:nvSpPr>
-          <p:cNvPr id="31" name="TextBox 30"/>
+              <a:t>local Luna fixture decisions</a:t>
+            </a:r>
+          </a:p>
+        </p:txBody>
+      </p:sp>
+      <p:sp>
+        <p:nvSpPr>
+          <p:cNvPr id="30" name="TextBox 29"/>
           <p:cNvSpPr txBox="1"/>
           <p:nvPr/>
         </p:nvSpPr>
         <p:spPr>
           <a:xfrm>
-            <a:off x="5330952" y="6583680"/>
-            <a:ext cx="3849624" cy="438912"/>
+            <a:off x="5330952" y="5477256"/>
+            <a:ext cx="3849624" cy="429768"/>
           </a:xfrm>
           <a:prstGeom prst="rect">
             <a:avLst/>
@@ -14590,7 +14595,7 @@
                 </a:solidFill>
                 <a:latin typeface="Aptos"/>
               </a:rPr>
-              <a:t>Recorded frozen rc.1 checks</a:t>
+              <a:t>50 ES + 50 PT</a:t>
             </a:r>
           </a:p>
           <a:p>
@@ -14606,21 +14611,21 @@
                 </a:solidFill>
                 <a:latin typeface="Aptos"/>
               </a:rPr>
-              <a:t>Build + ownership + recovery coverage</a:t>
-            </a:r>
-          </a:p>
-        </p:txBody>
-      </p:sp>
-      <p:sp>
-        <p:nvSpPr>
-          <p:cNvPr id="32" name="Rounded Rectangle 31"/>
+              <a:t>Grounded expected decisions</a:t>
+            </a:r>
+          </a:p>
+        </p:txBody>
+      </p:sp>
+      <p:sp>
+        <p:nvSpPr>
+          <p:cNvPr id="31" name="Rounded Rectangle 30"/>
           <p:cNvSpPr/>
           <p:nvPr/>
         </p:nvSpPr>
         <p:spPr>
           <a:xfrm>
-            <a:off x="9582912" y="5367528"/>
-            <a:ext cx="4206240" cy="1719072"/>
+            <a:off x="9582912" y="4325112"/>
+            <a:ext cx="4206240" cy="1755648"/>
           </a:xfrm>
           <a:prstGeom prst="roundRect">
             <a:avLst>
@@ -14658,14 +14663,14 @@
       </p:sp>
       <p:sp>
         <p:nvSpPr>
-          <p:cNvPr id="33" name="TextBox 32"/>
+          <p:cNvPr id="32" name="TextBox 31"/>
           <p:cNvSpPr txBox="1"/>
           <p:nvPr/>
         </p:nvSpPr>
         <p:spPr>
           <a:xfrm>
-            <a:off x="9756648" y="5541264"/>
-            <a:ext cx="3849624" cy="566928"/>
+            <a:off x="9756648" y="4471416"/>
+            <a:ext cx="3849624" cy="530352"/>
           </a:xfrm>
           <a:prstGeom prst="rect">
             <a:avLst/>
@@ -14684,27 +14689,27 @@
               </a:spcAft>
             </a:pPr>
             <a:r>
-              <a:rPr sz="2300" b="1">
+              <a:rPr sz="3200" b="1">
                 <a:solidFill>
                   <a:srgbClr val="D9EDB7"/>
                 </a:solidFill>
                 <a:latin typeface="Aptos"/>
               </a:rPr>
-              <a:t>Run → tool → agent</a:t>
-            </a:r>
-          </a:p>
-        </p:txBody>
-      </p:sp>
-      <p:sp>
-        <p:nvSpPr>
-          <p:cNvPr id="34" name="TextBox 33"/>
+              <a:t>2 journeys</a:t>
+            </a:r>
+          </a:p>
+        </p:txBody>
+      </p:sp>
+      <p:sp>
+        <p:nvSpPr>
+          <p:cNvPr id="33" name="TextBox 32"/>
           <p:cNvSpPr txBox="1"/>
           <p:nvPr/>
         </p:nvSpPr>
         <p:spPr>
           <a:xfrm>
-            <a:off x="9756648" y="6181344"/>
-            <a:ext cx="3849624" cy="274320"/>
+            <a:off x="9756648" y="5084064"/>
+            <a:ext cx="3849624" cy="256032"/>
           </a:xfrm>
           <a:prstGeom prst="rect">
             <a:avLst/>
@@ -14729,21 +14734,21 @@
                 </a:solidFill>
                 <a:latin typeface="Aptos"/>
               </a:rPr>
-              <a:t>execution visibility</a:t>
-            </a:r>
-          </a:p>
-        </p:txBody>
-      </p:sp>
-      <p:sp>
-        <p:nvSpPr>
-          <p:cNvPr id="35" name="TextBox 34"/>
+              <a:t>live public API · card protection</a:t>
+            </a:r>
+          </a:p>
+        </p:txBody>
+      </p:sp>
+      <p:sp>
+        <p:nvSpPr>
+          <p:cNvPr id="34" name="TextBox 33"/>
           <p:cNvSpPr txBox="1"/>
           <p:nvPr/>
         </p:nvSpPr>
         <p:spPr>
           <a:xfrm>
-            <a:off x="9756648" y="6583680"/>
-            <a:ext cx="3849624" cy="438912"/>
+            <a:off x="9756648" y="5477256"/>
+            <a:ext cx="3849624" cy="429768"/>
           </a:xfrm>
           <a:prstGeom prst="rect">
             <a:avLst/>
@@ -14768,7 +14773,7 @@
                 </a:solidFill>
                 <a:latin typeface="Aptos"/>
               </a:rPr>
-              <a:t>FLUJO metadata statistics</a:t>
+              <a:t>Spanish + Portuguese: consent,</a:t>
             </a:r>
           </a:p>
           <a:p>
@@ -14784,8 +14789,53 @@
                 </a:solidFill>
                 <a:latin typeface="Aptos"/>
               </a:rPr>
-              <a:t>Durations, tokens, failures, revisions</a:t>
-            </a:r>
+              <a:t>verified block and status on new login</a:t>
+            </a:r>
+          </a:p>
+        </p:txBody>
+      </p:sp>
+      <p:sp>
+        <p:nvSpPr>
+          <p:cNvPr id="35" name="Rounded Rectangle 34"/>
+          <p:cNvSpPr/>
+          <p:nvPr/>
+        </p:nvSpPr>
+        <p:spPr>
+          <a:xfrm>
+            <a:off x="731520" y="6327648"/>
+            <a:ext cx="13057632" cy="914400"/>
+          </a:xfrm>
+          <a:prstGeom prst="roundRect">
+            <a:avLst>
+              <a:gd name="adj" fmla="val 12000"/>
+            </a:avLst>
+          </a:prstGeom>
+          <a:solidFill>
+            <a:srgbClr val="214A3F"/>
+          </a:solidFill>
+          <a:ln>
+            <a:noFill/>
+          </a:ln>
+        </p:spPr>
+        <p:style>
+          <a:lnRef idx="1">
+            <a:schemeClr val="accent1"/>
+          </a:lnRef>
+          <a:fillRef idx="3">
+            <a:schemeClr val="accent1"/>
+          </a:fillRef>
+          <a:effectRef idx="2">
+            <a:schemeClr val="accent1"/>
+          </a:effectRef>
+          <a:fontRef idx="minor">
+            <a:schemeClr val="lt1"/>
+          </a:fontRef>
+        </p:style>
+        <p:txBody>
+          <a:bodyPr rtlCol="0" anchor="ctr"/>
+          <a:lstStyle/>
+          <a:p>
+            <a:pPr algn="ctr"/>
           </a:p>
         </p:txBody>
       </p:sp>
@@ -14797,8 +14847,86 @@
         </p:nvSpPr>
         <p:spPr>
           <a:xfrm>
-            <a:off x="749808" y="7306056"/>
-            <a:ext cx="13167360" cy="338328"/>
+            <a:off x="914400" y="6455664"/>
+            <a:ext cx="12664440" cy="192024"/>
+          </a:xfrm>
+          <a:prstGeom prst="rect">
+            <a:avLst/>
+          </a:prstGeom>
+          <a:noFill/>
+        </p:spPr>
+        <p:txBody>
+          <a:bodyPr wrap="square" lIns="9144" rIns="9144" tIns="0" bIns="0" anchor="t">
+            <a:spAutoFit/>
+          </a:bodyPr>
+          <a:lstStyle/>
+          <a:p>
+            <a:pPr>
+              <a:spcAft>
+                <a:spcPts val="200"/>
+              </a:spcAft>
+            </a:pPr>
+            <a:r>
+              <a:rPr sz="900" b="1">
+                <a:solidFill>
+                  <a:srgbClr val="D9EDB7"/>
+                </a:solidFill>
+                <a:latin typeface="Aptos"/>
+              </a:rPr>
+              <a:t>DATA → PRODUCT DECISION</a:t>
+            </a:r>
+          </a:p>
+        </p:txBody>
+      </p:sp>
+      <p:sp>
+        <p:nvSpPr>
+          <p:cNvPr id="37" name="TextBox 36"/>
+          <p:cNvSpPr txBox="1"/>
+          <p:nvPr/>
+        </p:nvSpPr>
+        <p:spPr>
+          <a:xfrm>
+            <a:off x="914400" y="6766560"/>
+            <a:ext cx="12664440" cy="256032"/>
+          </a:xfrm>
+          <a:prstGeom prst="rect">
+            <a:avLst/>
+          </a:prstGeom>
+          <a:noFill/>
+        </p:spPr>
+        <p:txBody>
+          <a:bodyPr wrap="square" lIns="9144" rIns="9144" tIns="0" bIns="0" anchor="t">
+            <a:spAutoFit/>
+          </a:bodyPr>
+          <a:lstStyle/>
+          <a:p>
+            <a:pPr>
+              <a:spcAft>
+                <a:spcPts val="200"/>
+              </a:spcAft>
+            </a:pPr>
+            <a:r>
+              <a:rPr sz="1700" b="1">
+                <a:solidFill>
+                  <a:srgbClr val="F8F8F2"/>
+                </a:solidFill>
+                <a:latin typeface="Aptos"/>
+              </a:rPr>
+              <a:t>Historical links crossed customer ownership. New inquiries use owned transaction reads.</a:t>
+            </a:r>
+          </a:p>
+        </p:txBody>
+      </p:sp>
+      <p:sp>
+        <p:nvSpPr>
+          <p:cNvPr id="38" name="TextBox 37"/>
+          <p:cNvSpPr txBox="1"/>
+          <p:nvPr/>
+        </p:nvSpPr>
+        <p:spPr>
+          <a:xfrm>
+            <a:off x="749808" y="7434072"/>
+            <a:ext cx="13167360" cy="210312"/>
           </a:xfrm>
           <a:prstGeom prst="rect">
             <a:avLst/>
@@ -14823,46 +14951,7 @@
                 </a:solidFill>
                 <a:latin typeface="Aptos"/>
               </a:rPr>
-              <a:t>Benchmark: Qwen3.8-27B FP8 + vLLM on rented H100. Current demo: direct provider; FLUJO fleet is the integration target.</a:t>
-            </a:r>
-          </a:p>
-        </p:txBody>
-      </p:sp>
-      <p:sp>
-        <p:nvSpPr>
-          <p:cNvPr id="37" name="TextBox 36"/>
-          <p:cNvSpPr txBox="1"/>
-          <p:nvPr/>
-        </p:nvSpPr>
-        <p:spPr>
-          <a:xfrm>
-            <a:off x="749808" y="7534656"/>
-            <a:ext cx="13167360" cy="210312"/>
-          </a:xfrm>
-          <a:prstGeom prst="rect">
-            <a:avLst/>
-          </a:prstGeom>
-          <a:noFill/>
-        </p:spPr>
-        <p:txBody>
-          <a:bodyPr wrap="square" lIns="9144" rIns="9144" tIns="0" bIns="0" anchor="t">
-            <a:spAutoFit/>
-          </a:bodyPr>
-          <a:lstStyle/>
-          <a:p>
-            <a:pPr>
-              <a:spcAft>
-                <a:spcPts val="200"/>
-              </a:spcAft>
-            </a:pPr>
-            <a:r>
-              <a:rPr sz="900" b="0">
-                <a:solidFill>
-                  <a:srgbClr val="C6D3CA"/>
-                </a:solidFill>
-                <a:latin typeface="Aptos"/>
-              </a:rPr>
-              <a:t>Case state persists; active audio resets after restart. Capacity is a workload result, not 300 simultaneous GPU generations.</a:t>
+              <a:t>Savia + Banking MCP own the banking boundary. FLUJO keeps its generic interfaces; voice and models remain replaceable.</a:t>
             </a:r>
           </a:p>
         </p:txBody>
@@ -15009,7 +15098,7 @@
                 </a:solidFill>
                 <a:latin typeface="Aptos"/>
               </a:rPr>
-              <a:t>SAVIA  /  ONE VOICE. A NETWORK BEHIND IT.</a:t>
+              <a:t>SAVIA  /  ASK ONCE. SAVIA FOLLOWS THROUGH.</a:t>
             </a:r>
           </a:p>
         </p:txBody>

</xml_diff>

<commit_message>
Make Savia's product pitch lead with customer value and card control (#76)
* Put the customer pitch and confirmed card control first

* Fix public reading-copy links after portal relocation

* Publish usable evidence links and align the policy implementation note

* Pin separate portal source without weakening runtime verification

* Preserve complete-submission independent review cohort and scope clarification

* Record healthy product pitch publication and unchanged runtime proof

---------

Co-authored-by: flujo-app <300233937+flujo-app@users.noreply.github.com>
</commit_message>
<xml_diff>
--- a/docs/submission/media/decks/final/savia-final-pitch.pptx
+++ b/docs/submission/media/decks/final/savia-final-pitch.pptx
@@ -507,23 +507,23 @@
           <a:lstStyle/>
           <a:p>
             <a:r>
-              <a:t>NARRATION (participant voice)</a:t>
-            </a:r>
-          </a:p>
-          <a:p>
-            <a:r>
-              <a:t>I don't recognize this transaction. For a customer, that is the start of a problem, not just a chat. Meet Savia: one voice assistant that keeps your case moving while you get on with your day. Behind that familiar voice is a network designed for up to one hundred agents.</a:t>
+              <a:t>SAY (participant voice)</a:t>
+            </a:r>
+          </a:p>
+          <a:p>
+            <a:r>
+              <a:t>I don't recognize this transaction. That can start a problem that takes more than one conversation to solve. Meet Savia: one assistant that keeps your case and brings back a useful next step. The charge stays visible, so the answer stays connected to the problem. Ask once. Savia follows through while you get on with your day.</a:t>
             </a:r>
           </a:p>
           <a:p/>
           <a:p>
             <a:r>
-              <a:t>EVIDENCE / Q&amp;A</a:t>
-            </a:r>
-          </a:p>
-          <a:p>
-            <a:r>
-              <a:t>Product vision: up to 100 team conversations. Working prototype: integrated voice, grounded explanation, durable inquiries and two completed reviewers. Transaction disputes are the first use case. Do not describe all 100 as proven simultaneous customer execution.</a:t>
+              <a:t>IF ASKED</a:t>
+            </a:r>
+          </a:p>
+          <a:p>
+            <a:r>
+              <a:t>Implemented core: deterministic R0–R18 dispute flow, owned facts, ordered policy, explicit consent, verified receipts, recovery and handoff. Recorded prototype: integrated voice, grounded explanation, durable inquiries and two completed model reviewers. Immediate fictional card protection has separate local and public API acceptance. Voice and larger collaborative fleets extend the trusted core; neither transfers its acceptance to a whole customer journey.</a:t>
             </a:r>
           </a:p>
           <a:p/>
@@ -534,12 +534,22 @@
           </a:p>
           <a:p>
             <a:r>
-              <a:t>https://github.com/mario-andreschak/factored-hackathon-2026-mcg/blob/95e2b9d62685f2669473258b88935a43dbe1bf75/docs/submission/CUSTOMER_JOURNEY.md</a:t>
-            </a:r>
-          </a:p>
-          <a:p>
-            <a:r>
-              <a:t>https://github.com/mario-andreschak/factored-hackathon-2026-mcg/blob/95e2b9d62685f2669473258b88935a43dbe1bf75/docs/submission/assistant/FLEET_CONNECTOR.md</a:t>
+              <a:t>https://github.com/mario-andreschak/factored-hackathon-2026-mcg/blob/7de0bbd670c25e4ad83476c6d7b70c45cc58a137/docs/DISPUTE_IMPLEMENTATION.md</a:t>
+            </a:r>
+          </a:p>
+          <a:p>
+            <a:r>
+              <a:t>https://github.com/mario-andreschak/factored-hackathon-2026-mcg/blob/7de0bbd670c25e4ad83476c6d7b70c45cc58a137/docs/submission/measurements/core-engine-final/README.md</a:t>
+            </a:r>
+          </a:p>
+          <a:p>
+            <a:r>
+              <a:t>https://github.com/mario-andreschak/factored-hackathon-2026-mcg/blob/7de0bbd670c25e4ad83476c6d7b70c45cc58a137/docs/submission/CUSTOMER_JOURNEY.md</a:t>
+            </a:r>
+          </a:p>
+          <a:p>
+            <a:r>
+              <a:t>https://github.com/mario-andreschak/factored-hackathon-2026-mcg/blob/7de0bbd670c25e4ad83476c6d7b70c45cc58a137/docs/submission/measurements/card-block-live/README.md</a:t>
             </a:r>
           </a:p>
         </p:txBody>
@@ -609,23 +619,23 @@
           <a:lstStyle/>
           <a:p>
             <a:r>
-              <a:t>NARRATION (participant voice)</a:t>
-            </a:r>
-          </a:p>
-          <a:p>
-            <a:r>
-              <a:t>Savia checks the selected transaction, explains what is known and takes permitted steps with your consent. If the answer needs investigation, the case keeps its context while specialists explore different approaches. Savia returns with a useful result or prepares the next human handoff. Our prototype already shows a grounded answer, two saved perspectives and a customer returning without starting over.</a:t>
+              <a:t>SAY (participant voice)</a:t>
+            </a:r>
+          </a:p>
+          <a:p>
+            <a:r>
+              <a:t>Select the unfamiliar charge. Savia explains the checked merchant, amount and status. Ask its specialists to compare evidence; their saved suggestions wait when you return. The recorded customer path includes a grounded answer, two completed reviewers, and saved recommendations after a new chat. Confirm once. Savia blocks the owned card, writes a durable status, and rereads an independent receipt. Asking never writes. Foreign cards, missing consent, and tampered receipts are refused.</a:t>
             </a:r>
           </a:p>
           <a:p/>
           <a:p>
             <a:r>
-              <a:t>EVIDENCE / Q&amp;A</a:t>
-            </a:r>
-          </a:p>
-          <a:p>
-            <a:r>
-              <a:t>Actual fictional Spanish UI is shown with an English summary. Demonstrated: selected grounded answer 9.338 s; separate browser team interaction 4.278 s; two suggestions survive new chat/reload; customer marks an informational inquiry helpful. Integrated voice closure has complete playback receipts. A separate simulated receipt check repeats after 30 real minutes. Real human assignment, bank resolution/refund, push/email delivery and multi-day completion remain unverified. The story rail describes the intended full lifecycle, not a recorded four-stage production run.</a:t>
+              <a:t>IF ASKED</a:t>
+            </a:r>
+          </a:p>
+          <a:p>
+            <a:r>
+              <a:t>Actual fictional Spanish UI is shown with an English summary. Recorded: grounded answer, two completed model reviewers, saved suggestions surviving new chat/reload and helpful informational closure. Complete native voice playback has receipts; a separate simulated receipt check repeats after 30 real minutes. New protection evidence consists of two public authenticated API journeys over fictional cards, not a new GUI or voice recording. Preparation leaves status unchanged; explicit consent precedes verified block readback, and a fresh login recovers it. Real human assignment, real-bank block/refund, push/email delivery and multi-day completion remain unverified. The story rail joins separately qualified capabilities; it is not a recorded production lifecycle.</a:t>
             </a:r>
           </a:p>
           <a:p/>
@@ -636,12 +646,22 @@
           </a:p>
           <a:p>
             <a:r>
-              <a:t>https://github.com/mario-andreschak/factored-hackathon-2026-mcg/blob/95e2b9d62685f2669473258b88935a43dbe1bf75/docs/submission/CUSTOMER_JOURNEY.md</a:t>
+              <a:t>https://github.com/mario-andreschak/factored-hackathon-2026-mcg/blob/7de0bbd670c25e4ad83476c6d7b70c45cc58a137/docs/submission/CUSTOMER_JOURNEY.md</a:t>
             </a:r>
           </a:p>
           <a:p>
             <a:r>
               <a:t>https://github.com/mario-andreschak/factored-hackathon-2026-mcg/blob/843da50698b559dc748bea4505d1d93483ff29b3/docs/submission/RELEASE_CANDIDATE.md</a:t>
+            </a:r>
+          </a:p>
+          <a:p>
+            <a:r>
+              <a:t>https://github.com/mario-andreschak/factored-hackathon-2026-mcg/blob/7de0bbd670c25e4ad83476c6d7b70c45cc58a137/docs/submission/measurements/CARD_BLOCK_VERIFICATION.md</a:t>
+            </a:r>
+          </a:p>
+          <a:p>
+            <a:r>
+              <a:t>https://github.com/mario-andreschak/factored-hackathon-2026-mcg/blob/7de0bbd670c25e4ad83476c6d7b70c45cc58a137/docs/submission/measurements/card-block-live/README.md</a:t>
             </a:r>
           </a:p>
         </p:txBody>
@@ -711,23 +731,23 @@
           <a:lstStyle/>
           <a:p>
             <a:r>
-              <a:t>NARRATION (participant voice)</a:t>
-            </a:r>
-          </a:p>
-          <a:p>
-            <a:r>
-              <a:t>ElevenLabs shows how compelling a natural transaction-dispute conversation can be. That is a commercial reference for voice quality. Savia makes the case itself the product: a persistent goal, multiple perspectives, reviewed findings and a deployment the bank can control. We are selling the service that keeps working after the conversation.</a:t>
+              <a:t>SAY (participant voice)</a:t>
+            </a:r>
+          </a:p>
+          <a:p>
+            <a:r>
+              <a:t>A polished voice is not a case. ElevenLabs is a commercial voice platform. Savia is the bank-controlled service: owned facts, deterministic policy, consent, receipt, follow-up, swarm investigation. We built that in ten days with two people.</a:t>
             </a:r>
           </a:p>
           <a:p/>
           <a:p>
             <a:r>
-              <a:t>EVIDENCE / Q&amp;A</a:t>
-            </a:r>
-          </a:p>
-          <a:p>
-            <a:r>
-              <a:t>Comparison reframes the supplied analysis as product positioning, not a winner table. ElevenLabs official September 28 article, updated October 5, reports expressive voice, about 100 ms median inference, 90+ languages, a financial-services dispute demo and a combined transcription/turn-taking/TTS stack. No head-to-head performance, stronger compliance or missing competitor features are asserted. Savia focus and proposed deployment options differ in scope from a commercial platform showcase.</a:t>
+              <a:t>IF ASKED</a:t>
+            </a:r>
+          </a:p>
+          <a:p>
+            <a:r>
+              <a:t>ElevenLabs official September 28 article, updated October 5 and checked October 5, reports expressive voice, about 100 ms median model inference, 90+ languages, a financial-services dispute showcase and a combined transcription/turn-taking/TTS stack. These are vendor-reported capabilities; no matched performance benchmark is available. The comparison describes Savia’s product emphasis and bank-controlled policy/action boundary. The two-person, ten-day delivery statement is owner-supplied; historical implementation credits for Gloria Yanta Salc, Carlos Diaz and Mario Andreschak remain preserved.</a:t>
             </a:r>
           </a:p>
           <a:p/>
@@ -743,7 +763,12 @@
           </a:p>
           <a:p>
             <a:r>
-              <a:t>https://github.com/mario-andreschak/factored-hackathon-2026-mcg/blob/95e2b9d62685f2669473258b88935a43dbe1bf75/docs/submission/assistant/FLEET_CONNECTOR.md</a:t>
+              <a:t>https://github.com/mario-andreschak/factored-hackathon-2026-mcg/blob/7de0bbd670c25e4ad83476c6d7b70c45cc58a137/docs/submission/ELEVENLABS_COMPARISON.md</a:t>
+            </a:r>
+          </a:p>
+          <a:p>
+            <a:r>
+              <a:t>https://github.com/mario-andreschak/factored-hackathon-2026-mcg/blob/7de0bbd670c25e4ad83476c6d7b70c45cc58a137/docs/FLUJO_PRODUCT_BOUNDARY.md</a:t>
             </a:r>
           </a:p>
         </p:txBody>
@@ -813,23 +838,23 @@
           <a:lstStyle/>
           <a:p>
             <a:r>
-              <a:t>NARRATION (participant voice)</a:t>
-            </a:r>
-          </a:p>
-          <a:p>
-            <a:r>
-              <a:t>One assistant stays with the customer. The swarm design spreads the investigation across ten teams: one lead and nine specialists per team, one hundred agent conversations in total. They exchange messages, share evidence, challenge findings and return a reviewed synthesis. FLUJO provides the orchestration foundation; Savia owns the case. Existing sandbox collaboration and capacity tests support this design. The exact hundred-agent customer run still needs qualification.</a:t>
+              <a:t>SAY (participant voice)</a:t>
+            </a:r>
+          </a:p>
+          <a:p>
+            <a:r>
+              <a:t>One customer voice. Ten teams behind it. 300/300 concurrent FLUJO. 18 sandboxes live together. The customer path we recorded is two reviewers; the architecture is ready to scale.</a:t>
             </a:r>
           </a:p>
           <a:p/>
           <a:p>
             <a:r>
-              <a:t>EVIDENCE / Q&amp;A</a:t>
-            </a:r>
-          </a:p>
-          <a:p>
-            <a:r>
-              <a:t>Counting contract: 10 team Machines × (1 lead + 9 child specialists) = 100 team conversations; Savia root is separate. Configured child concurrency is nine; stock recovered flow used ten. Native subflow messaging/waiting; fleet delegation/message/wait; shared board and independent claim review. Real infrastructure evidence includes 18 simultaneous Fly leaf sandboxes, 17 completed leaf team runs, six matching output hashes; six of 24 leaf slots failed provisioning and operator steering was required. Larger recovered run enrolled 96 child Workers over time, not all simultaneously. Integrated customer attempt failed on first background root model call with disabled provider workspace before delegation. No 100-completion claim.</a:t>
+              <a:t>IF ASKED</a:t>
+            </a:r>
+          </a:p>
+          <a:p>
+            <a:r>
+              <a:t>Exact 100-agent customer completion has not yet been demonstrated; one later attempt ended on a disabled provider workspace before delegation. Diagram counting: ten team Machines × (one lead + nine child specialists) = 100 team conversations; the root coordinator is separate. The 300/300 foundation result is the repeat neutral reference-code workload with 300 concurrent client submissions queued through FLUJO, 1k context, Qwen3.8-27B FP8 and vLLM on a rented H100; it does not mean 300 simultaneous GPU generations or 300 customer investigations. Queue-inclusive p50/p95 were 273.40/441.60 seconds. First wording yielded 217/300 correct; direct inference yielded 399/400. Historical collaboration had 18 leaf sandboxes live together, 17 completed leaf team runs and six matching output hashes. Six of 24 leaf slots failed provisioning, and operator steering was required. The larger recovered run enrolled 96 child workers over time. These preserve the tested foundation and qualify the scale design; they are separate from the successful recorded two-reviewer customer path and the local Luna workload.</a:t>
             </a:r>
           </a:p>
           <a:p/>
@@ -840,12 +865,27 @@
           </a:p>
           <a:p>
             <a:r>
+              <a:t>https://github.com/mario-andreschak/factored-hackathon-2026-mcg/blob/7de0bbd670c25e4ad83476c6d7b70c45cc58a137/docs/submission/assistant/FLEET_CONNECTOR.md</a:t>
+            </a:r>
+          </a:p>
+          <a:p>
+            <a:r>
               <a:t>https://github.com/mario-andreschak/factored-hackathon-2026-mcg/blob/95e2b9d62685f2669473258b88935a43dbe1bf75/docs/submission/measurements/INFRASTRUCTURE_CAPACITY.md</a:t>
             </a:r>
           </a:p>
           <a:p>
             <a:r>
-              <a:t>https://github.com/mario-andreschak/factored-hackathon-2026-mcg/blob/95e2b9d62685f2669473258b88935a43dbe1bf75/docs/submission/assistant/FLEET_CONNECTOR.md</a:t>
+              <a:t>https://github.com/mario-andreschak/factored-hackathon-2026-mcg/blob/95e2b9d62685f2669473258b88935a43dbe1bf75/docs/submission/measurements/infrastructure-capacity.json</a:t>
+            </a:r>
+          </a:p>
+          <a:p>
+            <a:r>
+              <a:t>https://github.com/mario-andreschak/factored-hackathon-2026-mcg/blob/7de0bbd670c25e4ad83476c6d7b70c45cc58a137/docs/submission/CUSTOMER_JOURNEY.md</a:t>
+            </a:r>
+          </a:p>
+          <a:p>
+            <a:r>
+              <a:t>https://github.com/mario-andreschak/factored-hackathon-2026-mcg/blob/7de0bbd670c25e4ad83476c6d7b70c45cc58a137/docs/architecture/rc-runtime-reference.md</a:t>
             </a:r>
           </a:p>
         </p:txBody>
@@ -915,23 +955,23 @@
           <a:lstStyle/>
           <a:p>
             <a:r>
-              <a:t>NARRATION (participant voice)</a:t>
-            </a:r>
-          </a:p>
-          <a:p>
-            <a:r>
-              <a:t>The system is modular: customer voice, durable case state, FLUJO orchestration and scoped banking tools. Data ownership and consent stay in the host and Banking MCP. Choose local open-weight inference or a hosted provider. FLUJO exposes run, model, tool and subflow statistics. The foundation returned three hundred correct reference codes from three hundred queued requests. The frozen release also records one hundred twenty-nine frontend and three hundred sixty-seven backend tests.</a:t>
+              <a:t>SAY (participant voice)</a:t>
+            </a:r>
+          </a:p>
+          <a:p>
+            <a:r>
+              <a:t>Policy, not the model, authorizes the card action. Savia and Banking MCP own facts, nineteen ordered rules, consent and receipts. FLUJO remains the generic orchestration foundation. One thousand seventy-eight offline core checks exercise that boundary. One hundred local Luna fixture decisions matched their expected results. Two live Spanish and Portuguese API journeys verified card protection. The data audit taught us to ground new inquiries in owned transactions. The bank controls the stack and the next step.</a:t>
             </a:r>
           </a:p>
           <a:p/>
           <a:p>
             <a:r>
-              <a:t>EVIDENCE / Q&amp;A</a:t>
-            </a:r>
-          </a:p>
-          <a:p>
-            <a:r>
-              <a:t>Deployment design supports self-hosted services and model selection; FLUJO local Ollama path is source-documented, not a measured all-local Savia deployment. Capacity benchmark used Qwen3.8-27B FP8 with vLLM 0.30.0 on rented Modal H100: repeat neutral reference-code workload, 1k context, 300 client submissions, p50 273.40 s, p95 441.60 s including queueing. First wording returned 217/300 correct; direct inference returned 399/400 correct; both retained. Counts 129 frontend / 367 backend refer to frozen rc.1 checks, not a fresh whole-release CI claim (current CI has failures). Statistics are metadata-only and best-effort; not every payload is retained and not an audit completeness guarantee. Current public app calls OpenRouter directly; target connects the FLUJO worker fleet. Cases/chat persist on disk; active audio state does not survive restart. Interrupted/unknown work is held rather than blindly replayed. TLS ingress, signed consent-scoped boundaries and separated data/state are source-backed controls, not a compliance certification.</a:t>
+              <a:t>IF ASKED</a:t>
+            </a:r>
+          </a:p>
+          <a:p>
+            <a:r>
+              <a:t>Fresh core qualification: 1,078 passing checks, zero errors/failures/skips and no provider calls. It executed 14 suites; 39 core/domain source files independently match the deployed source. This does not establish all-repository CI or current end-to-end customer acceptance. Luna: 100 completed actual local subscription requests, 50 ES/50 PT, 10 distinct request phrases with varied fictional facts, exact frozen oracle and bounded no-action checks. Independent deterministic baseline also 100/100; no quality improvement, 100 collaborative agents, deployed GUI, bank writes or simultaneous GPU-generation claim. Public API protection: two actual ES/PT authenticated journeys on application f3c57b26, consent before a fictional block, verified receipt readback/retry and status recovered on fresh login; no new GUI or voice acceptance. Data-to-product decision: published complaint-product links violate customer ownership, so new inquiries use owned reads. Keep ownership and no-write rules deterministic. Savia/Banking MCP own domain data/policy/state; FLUJO main keeps generic chat/flow/tool/MCP interfaces. Source-documented local-model/deployment options are not a measured all-local Savia rollout. Historical queued reference-code capacity, including 300/300 repeat workload, remains separate extension evidence with failure and timing disclosures.</a:t>
             </a:r>
           </a:p>
           <a:p/>
@@ -942,32 +982,52 @@
           </a:p>
           <a:p>
             <a:r>
+              <a:t>https://github.com/mario-andreschak/factored-hackathon-2026-mcg/blob/7de0bbd670c25e4ad83476c6d7b70c45cc58a137/docs/submission/measurements/core-engine-final/README.md</a:t>
+            </a:r>
+          </a:p>
+          <a:p>
+            <a:r>
+              <a:t>https://github.com/mario-andreschak/factored-hackathon-2026-mcg/blob/7de0bbd670c25e4ad83476c6d7b70c45cc58a137/docs/submission/measurements/luna-100/README.md</a:t>
+            </a:r>
+          </a:p>
+          <a:p>
+            <a:r>
+              <a:t>https://github.com/mario-andreschak/factored-hackathon-2026-mcg/blob/7de0bbd670c25e4ad83476c6d7b70c45cc58a137/docs/submission/measurements/card-block-live/README.md</a:t>
+            </a:r>
+          </a:p>
+          <a:p>
+            <a:r>
+              <a:t>https://github.com/mario-andreschak/factored-hackathon-2026-mcg/blob/f3c57b26d07c1e96b6e61a25befcbbc5fd51a17f/frontend/server/app.py</a:t>
+            </a:r>
+          </a:p>
+          <a:p>
+            <a:r>
+              <a:t>https://github.com/mario-andreschak/factored-hackathon-2026-mcg/blob/7de0bbd670c25e4ad83476c6d7b70c45cc58a137/docs/review/OPERATING_DECISIONS.md</a:t>
+            </a:r>
+          </a:p>
+          <a:p>
+            <a:r>
+              <a:t>https://github.com/mario-andreschak/factored-hackathon-2026-mcg/blob/7de0bbd670c25e4ad83476c6d7b70c45cc58a137/docs/FLUJO_PRODUCT_BOUNDARY.md</a:t>
+            </a:r>
+          </a:p>
+          <a:p>
+            <a:r>
+              <a:t>https://github.com/mario-andreschak/factored-hackathon-2026-mcg/blob/7de0bbd670c25e4ad83476c6d7b70c45cc58a137/docs/architecture/system-landscape.md</a:t>
+            </a:r>
+          </a:p>
+          <a:p>
+            <a:r>
+              <a:t>https://github.com/mario-andreschak/FLUJO/blob/main/docs/features/models/connecting.md</a:t>
+            </a:r>
+          </a:p>
+          <a:p>
+            <a:r>
               <a:t>https://github.com/mario-andreschak/factored-hackathon-2026-mcg/blob/95e2b9d62685f2669473258b88935a43dbe1bf75/docs/submission/measurements/INFRASTRUCTURE_CAPACITY.md</a:t>
             </a:r>
           </a:p>
           <a:p>
             <a:r>
               <a:t>https://github.com/mario-andreschak/factored-hackathon-2026-mcg/blob/95e2b9d62685f2669473258b88935a43dbe1bf75/docs/submission/measurements/infrastructure-capacity.json</a:t>
-            </a:r>
-          </a:p>
-          <a:p>
-            <a:r>
-              <a:t>https://github.com/mario-andreschak/factored-hackathon-2026-mcg/blob/843da50698b559dc748bea4505d1d93483ff29b3/docs/submission/RELEASE_CANDIDATE.md</a:t>
-            </a:r>
-          </a:p>
-          <a:p>
-            <a:r>
-              <a:t>C:\Users\Moe\Documents\GitHub\FLUJO\docs\features\models\connecting.md</a:t>
-            </a:r>
-          </a:p>
-          <a:p>
-            <a:r>
-              <a:t>C:\Users\Moe\Documents\GitHub\FLUJO\docs\statistics.md</a:t>
-            </a:r>
-          </a:p>
-          <a:p>
-            <a:r>
-              <a:t>C:\Users\Moe\Documents\GitHub\factored-hackathon-2026\docs\architecture\rc-runtime-reference.md</a:t>
             </a:r>
           </a:p>
         </p:txBody>
@@ -1037,18 +1097,18 @@
           <a:lstStyle/>
           <a:p>
             <a:r>
-              <a:t>NARRATION (participant voice)</a:t>
-            </a:r>
-          </a:p>
-          <a:p>
-            <a:r>
-              <a:t>For customers, the ambition is less chasing and less repeating. For the bank, it is clearer evidence and a better prepared handoff. Start with transaction disputes, then reuse the same modular service for other customer problems. We are seeking a bank partner for a bounded pilot: measure repeat contacts, helpful answers, handoff quality and cost per case. Ask once. Savia follows through.</a:t>
+              <a:t>SAY (participant voice)</a:t>
+            </a:r>
+          </a:p>
+          <a:p>
+            <a:r>
+              <a:t>For customers, the ambition is less chasing and less repeating. For the bank, it is clearer evidence and a better prepared handoff. Start with transaction disputes, then reuse the same modular service for other customer problems. We are seeking a bank partner for a bounded pilot: measure repeat contacts, helpful answers, handoff quality and cost per case. Measure the service on real customer needs, with a small rollout and a clear review gate. Ask once. Savia follows through.</a:t>
             </a:r>
           </a:p>
           <a:p/>
           <a:p>
             <a:r>
-              <a:t>EVIDENCE / Q&amp;A</a:t>
+              <a:t>IF ASKED</a:t>
             </a:r>
           </a:p>
           <a:p>
@@ -1064,7 +1124,7 @@
           </a:p>
           <a:p>
             <a:r>
-              <a:t>https://github.com/mario-andreschak/factored-hackathon-2026-mcg/blob/95e2b9d62685f2669473258b88935a43dbe1bf75/docs/submission/CUSTOMER_JOURNEY.md</a:t>
+              <a:t>https://github.com/mario-andreschak/factored-hackathon-2026-mcg/blob/7de0bbd670c25e4ad83476c6d7b70c45cc58a137/docs/submission/CUSTOMER_JOURNEY.md</a:t>
             </a:r>
           </a:p>
           <a:p>
@@ -4199,7 +4259,7 @@
                 </a:solidFill>
                 <a:latin typeface="Aptos"/>
               </a:rPr>
-              <a:t>SAVIA  /  ONE VOICE. A NETWORK BEHIND IT.</a:t>
+              <a:t>SAVIA  /  ASK ONCE. SAVIA FOLLOWS THROUGH.</a:t>
             </a:r>
           </a:p>
         </p:txBody>
@@ -4348,7 +4408,7 @@
                 </a:solidFill>
                 <a:latin typeface="Aptos"/>
               </a:rPr>
-              <a:t>A network designed for up to 100 agents on your case.</a:t>
+              <a:t>A case that keeps its context.</a:t>
             </a:r>
           </a:p>
         </p:txBody>
@@ -5370,7 +5430,7 @@
                 </a:solidFill>
                 <a:latin typeface="Aptos"/>
               </a:rPr>
-              <a:t>Product vision.</a:t>
+              <a:t>Checked facts.</a:t>
             </a:r>
           </a:p>
           <a:p>
@@ -5386,7 +5446,7 @@
                 </a:solidFill>
                 <a:latin typeface="Aptos"/>
               </a:rPr>
-              <a:t>Working prototype.</a:t>
+              <a:t>A saved next step.</a:t>
             </a:r>
           </a:p>
         </p:txBody>
@@ -5533,7 +5593,7 @@
                 </a:solidFill>
                 <a:latin typeface="Aptos"/>
               </a:rPr>
-              <a:t>SAVIA  /  ONE VOICE. A NETWORK BEHIND IT.</a:t>
+              <a:t>SAVIA  /  ASK ONCE. SAVIA FOLLOWS THROUGH.</a:t>
             </a:r>
           </a:p>
         </p:txBody>
@@ -5783,7 +5843,7 @@
                 </a:solidFill>
                 <a:latin typeface="Aptos"/>
               </a:rPr>
-              <a:t>Ask</a:t>
+              <a:t>Check</a:t>
             </a:r>
           </a:p>
         </p:txBody>
@@ -5822,7 +5882,7 @@
                 </a:solidFill>
                 <a:latin typeface="Aptos"/>
               </a:rPr>
-              <a:t>One assistant hears your story.</a:t>
+              <a:t>Understand your selected charge.</a:t>
             </a:r>
           </a:p>
         </p:txBody>
@@ -5978,7 +6038,7 @@
                 </a:solidFill>
                 <a:latin typeface="Aptos"/>
               </a:rPr>
-              <a:t>Act</a:t>
+              <a:t>Protect</a:t>
             </a:r>
           </a:p>
         </p:txBody>
@@ -6017,7 +6077,7 @@
                 </a:solidFill>
                 <a:latin typeface="Aptos"/>
               </a:rPr>
-              <a:t>Permitted steps, with consent.</a:t>
+              <a:t>Confirm once. Block your owned card.</a:t>
             </a:r>
           </a:p>
         </p:txBody>
@@ -6173,7 +6233,7 @@
                 </a:solidFill>
                 <a:latin typeface="Aptos"/>
               </a:rPr>
-              <a:t>Investigate</a:t>
+              <a:t>Explore</a:t>
             </a:r>
           </a:p>
         </p:txBody>
@@ -6212,7 +6272,7 @@
                 </a:solidFill>
                 <a:latin typeface="Aptos"/>
               </a:rPr>
-              <a:t>Specialists compare evidence.</a:t>
+              <a:t>Specialists compare the evidence.</a:t>
             </a:r>
           </a:p>
         </p:txBody>
@@ -6372,7 +6432,7 @@
                 </a:solidFill>
                 <a:latin typeface="Aptos"/>
               </a:rPr>
-              <a:t>A result or a human handoff.</a:t>
+              <a:t>Read your saved answer and next step.</a:t>
             </a:r>
           </a:p>
         </p:txBody>
@@ -6456,7 +6516,7 @@
                 </a:solidFill>
                 <a:latin typeface="Aptos"/>
               </a:rPr>
-              <a:t>DEMONSTRATED IN THE PROTOTYPE</a:t>
+              <a:t>CARD PROTECTION / COMPLETED ACTION</a:t>
             </a:r>
           </a:p>
         </p:txBody>
@@ -6469,8 +6529,8 @@
         </p:nvSpPr>
         <p:spPr>
           <a:xfrm>
-            <a:off x="932688" y="6227064"/>
-            <a:ext cx="8915400" cy="566928"/>
+            <a:off x="932688" y="6190488"/>
+            <a:ext cx="8915400" cy="896112"/>
           </a:xfrm>
           <a:prstGeom prst="rect">
             <a:avLst/>
@@ -6489,29 +6549,13 @@
               </a:spcAft>
             </a:pPr>
             <a:r>
-              <a:rPr sz="1800" b="0">
+              <a:rPr sz="1600" b="0">
                 <a:solidFill>
                   <a:srgbClr val="F8F8F2"/>
                 </a:solidFill>
                 <a:latin typeface="Aptos"/>
               </a:rPr>
-              <a:t>Grounded answer · two saved perspectives</a:t>
-            </a:r>
-          </a:p>
-          <a:p>
-            <a:pPr>
-              <a:spcAft>
-                <a:spcPts val="200"/>
-              </a:spcAft>
-            </a:pPr>
-            <a:r>
-              <a:rPr sz="1800" b="0">
-                <a:solidFill>
-                  <a:srgbClr val="F8F8F2"/>
-                </a:solidFill>
-                <a:latin typeface="Aptos"/>
-              </a:rPr>
-              <a:t>Return after a new chat without starting over</a:t>
+              <a:t>Confirm once. Savia blocks the owned card, writes a durable status, and rereads an independent receipt. Asking never writes. Foreign cards, missing consent, and tampered receipts are refused.</a:t>
             </a:r>
           </a:p>
         </p:txBody>
@@ -6613,7 +6657,7 @@
                 </a:solidFill>
                 <a:latin typeface="Aptos"/>
               </a:rPr>
-              <a:t>Product journey shown above; human pickup and bank resolution are pilot integrations. Fictional UI capture.</a:t>
+              <a:t>Demo ledger. Same admission rules a production host would use.</a:t>
             </a:r>
           </a:p>
         </p:txBody>
@@ -6760,7 +6804,7 @@
                 </a:solidFill>
                 <a:latin typeface="Aptos"/>
               </a:rPr>
-              <a:t>SAVIA  /  ONE VOICE. A NETWORK BEHIND IT.</a:t>
+              <a:t>SAVIA  /  ASK ONCE. SAVIA FOLLOWS THROUGH.</a:t>
             </a:r>
           </a:p>
         </p:txBody>
@@ -7132,7 +7176,7 @@
                 </a:solidFill>
                 <a:latin typeface="Aptos"/>
               </a:rPr>
-              <a:t>SAVIA / CASE ORCHESTRATION</a:t>
+              <a:t>SAVIA / THE CONTINUING CASE</a:t>
             </a:r>
           </a:p>
         </p:txBody>
@@ -7210,7 +7254,7 @@
                 </a:solidFill>
                 <a:latin typeface="Aptos"/>
               </a:rPr>
-              <a:t>Persistent goal and saved context</a:t>
+              <a:t>Checked facts and ordered decisions</a:t>
             </a:r>
           </a:p>
           <a:p>
@@ -7226,7 +7270,7 @@
                 </a:solidFill>
                 <a:latin typeface="Aptos"/>
               </a:rPr>
-              <a:t>Up to 100 agents in the swarm design</a:t>
+              <a:t>Explicit consent and saved receipts</a:t>
             </a:r>
           </a:p>
           <a:p>
@@ -7242,7 +7286,7 @@
                 </a:solidFill>
                 <a:latin typeface="Aptos"/>
               </a:rPr>
-              <a:t>Bank-controlled data and model choices</a:t>
+              <a:t>Saved context and specialist perspectives</a:t>
             </a:r>
           </a:p>
         </p:txBody>
@@ -7281,7 +7325,7 @@
                 </a:solidFill>
                 <a:latin typeface="Aptos"/>
               </a:rPr>
-              <a:t>A familiar voice. A persistent case. A network you control.</a:t>
+              <a:t>A familiar voice. A persistent case. A clear next step.</a:t>
             </a:r>
           </a:p>
         </p:txBody>
@@ -7314,13 +7358,13 @@
               </a:spcAft>
             </a:pPr>
             <a:r>
-              <a:rPr sz="1000" b="0">
+              <a:rPr sz="1200" b="0">
                 <a:solidFill>
                   <a:srgbClr val="C6D3CA"/>
                 </a:solidFill>
                 <a:latin typeface="Aptos"/>
               </a:rPr>
-              <a:t>Comparison of product emphasis; no head-to-head benchmark or claim of exclusive capabilities.</a:t>
+              <a:t>Two people. Ten days. A service the bank can inspect and control.</a:t>
             </a:r>
           </a:p>
         </p:txBody>
@@ -7469,7 +7513,7 @@
                 </a:solidFill>
                 <a:latin typeface="Aptos"/>
               </a:rPr>
-              <a:t>03 / THE AI SWARM</a:t>
+              <a:t>03 / THE SWARM DESIGN</a:t>
             </a:r>
           </a:p>
         </p:txBody>
@@ -7508,7 +7552,7 @@
                 </a:solidFill>
                 <a:latin typeface="Aptos"/>
               </a:rPr>
-              <a:t>SAVIA  /  ONE VOICE. A NETWORK BEHIND IT.</a:t>
+              <a:t>SAVIA  /  ASK ONCE. SAVIA FOLLOWS THROUGH.</a:t>
             </a:r>
           </a:p>
         </p:txBody>
@@ -7586,7 +7630,7 @@
                 </a:solidFill>
                 <a:latin typeface="Aptos"/>
               </a:rPr>
-              <a:t>One conversation.</a:t>
+              <a:t>One customer voice.</a:t>
             </a:r>
           </a:p>
           <a:p>
@@ -7602,7 +7646,7 @@
                 </a:solidFill>
                 <a:latin typeface="Aptos"/>
               </a:rPr>
-              <a:t>Up to 100 agents behind it.</a:t>
+              <a:t>Ten teams behind it.</a:t>
             </a:r>
           </a:p>
         </p:txBody>
@@ -7719,7 +7763,7 @@
                 </a:solidFill>
                 <a:latin typeface="Aptos"/>
               </a:rPr>
-              <a:t>10 teams × (1 lead + 9 specialists)</a:t>
+              <a:t>SWARM DESIGN</a:t>
             </a:r>
           </a:p>
           <a:p>
@@ -7735,7 +7779,7 @@
                 </a:solidFill>
                 <a:latin typeface="Aptos"/>
               </a:rPr>
-              <a:t>Savia’s coordinator is separate.</a:t>
+              <a:t>10 teams × (1 lead + 9 specialists)</a:t>
             </a:r>
           </a:p>
         </p:txBody>
@@ -12914,7 +12958,7 @@
                 </a:solidFill>
                 <a:latin typeface="Aptos"/>
               </a:rPr>
-              <a:t>LEAD + SPECIALISTS  /  SHARED EVIDENCE  /  INDEPENDENT REVIEW</a:t>
+              <a:t>SHARED EVIDENCE  /  SPECIALIST COLLABORATION  /  INDEPENDENT REVIEW</a:t>
             </a:r>
           </a:p>
         </p:txBody>
@@ -12998,7 +13042,7 @@
                 </a:solidFill>
                 <a:latin typeface="Aptos"/>
               </a:rPr>
-              <a:t>Communicate</a:t>
+              <a:t>300 / 300</a:t>
             </a:r>
           </a:p>
         </p:txBody>
@@ -13037,7 +13081,7 @@
                 </a:solidFill>
                 <a:latin typeface="Aptos"/>
               </a:rPr>
-              <a:t>Native messages + fleet relay</a:t>
+              <a:t>Concurrent FLUJO reference returns</a:t>
             </a:r>
           </a:p>
         </p:txBody>
@@ -13121,7 +13165,7 @@
                 </a:solidFill>
                 <a:latin typeface="Aptos"/>
               </a:rPr>
-              <a:t>Challenge</a:t>
+              <a:t>18 live together</a:t>
             </a:r>
           </a:p>
         </p:txBody>
@@ -13160,7 +13204,7 @@
                 </a:solidFill>
                 <a:latin typeface="Aptos"/>
               </a:rPr>
-              <a:t>Shared board + peer review</a:t>
+              <a:t>Sandboxes in the tested foundation</a:t>
             </a:r>
           </a:p>
         </p:txBody>
@@ -13244,7 +13288,7 @@
                 </a:solidFill>
                 <a:latin typeface="Aptos"/>
               </a:rPr>
-              <a:t>Recover</a:t>
+              <a:t>Two completed reviewers</a:t>
             </a:r>
           </a:p>
         </p:txBody>
@@ -13283,7 +13327,7 @@
                 </a:solidFill>
                 <a:latin typeface="Aptos"/>
               </a:rPr>
-              <a:t>Saved context; hold uncertain retries</a:t>
+              <a:t>The customer path we recorded</a:t>
             </a:r>
           </a:p>
         </p:txBody>
@@ -13316,13 +13360,13 @@
               </a:spcAft>
             </a:pPr>
             <a:r>
-              <a:rPr sz="1100" b="0">
+              <a:rPr sz="1200" b="0">
                 <a:solidFill>
-                  <a:srgbClr val="E9C977"/>
+                  <a:srgbClr val="D9EDB7"/>
                 </a:solidFill>
                 <a:latin typeface="Aptos"/>
               </a:rPr>
-              <a:t>Swarm design and deployed connector. Exact 100-agent customer completion remains to be qualified.</a:t>
+              <a:t>One customer voice. Ten teams behind it. The architecture is ready to scale.</a:t>
             </a:r>
           </a:p>
         </p:txBody>
@@ -13430,7 +13474,7 @@
                 </a:solidFill>
                 <a:latin typeface="Aptos"/>
               </a:rPr>
-              <a:t>04 / DEPLOYMENT, DATA &amp; PROOF</a:t>
+              <a:t>04 / QUALIFIED PROOF &amp; DATA DECISIONS</a:t>
             </a:r>
           </a:p>
         </p:txBody>
@@ -13469,7 +13513,7 @@
                 </a:solidFill>
                 <a:latin typeface="Aptos"/>
               </a:rPr>
-              <a:t>SAVIA  /  ONE VOICE. A NETWORK BEHIND IT.</a:t>
+              <a:t>SAVIA  /  ASK ONCE. SAVIA FOLLOWS THROUGH.</a:t>
             </a:r>
           </a:p>
         </p:txBody>
@@ -13547,7 +13591,7 @@
                 </a:solidFill>
                 <a:latin typeface="Aptos"/>
               </a:rPr>
-              <a:t>The bank controls the stack.</a:t>
+              <a:t>Evidence you can inspect.</a:t>
             </a:r>
           </a:p>
           <a:p>
@@ -13563,21 +13607,60 @@
                 </a:solidFill>
                 <a:latin typeface="Aptos"/>
               </a:rPr>
-              <a:t>The work leaves a trace.</a:t>
-            </a:r>
-          </a:p>
-        </p:txBody>
-      </p:sp>
-      <p:sp>
-        <p:nvSpPr>
-          <p:cNvPr id="7" name="Rounded Rectangle 6"/>
+              <a:t>Choices a bank can control.</a:t>
+            </a:r>
+          </a:p>
+        </p:txBody>
+      </p:sp>
+      <p:sp>
+        <p:nvSpPr>
+          <p:cNvPr id="7" name="TextBox 6"/>
+          <p:cNvSpPr txBox="1"/>
+          <p:nvPr/>
+        </p:nvSpPr>
+        <p:spPr>
+          <a:xfrm>
+            <a:off x="749808" y="2651760"/>
+            <a:ext cx="13075920" cy="365760"/>
+          </a:xfrm>
+          <a:prstGeom prst="rect">
+            <a:avLst/>
+          </a:prstGeom>
+          <a:noFill/>
+        </p:spPr>
+        <p:txBody>
+          <a:bodyPr wrap="square" lIns="9144" rIns="9144" tIns="0" bIns="0" anchor="t">
+            <a:spAutoFit/>
+          </a:bodyPr>
+          <a:lstStyle/>
+          <a:p>
+            <a:pPr>
+              <a:spcAft>
+                <a:spcPts val="200"/>
+              </a:spcAft>
+            </a:pPr>
+            <a:r>
+              <a:rPr sz="2200" b="1">
+                <a:solidFill>
+                  <a:srgbClr val="D9EDB7"/>
+                </a:solidFill>
+                <a:latin typeface="Aptos"/>
+              </a:rPr>
+              <a:t>Policy, not the model, authorizes the card action.</a:t>
+            </a:r>
+          </a:p>
+        </p:txBody>
+      </p:sp>
+      <p:sp>
+        <p:nvSpPr>
+          <p:cNvPr id="8" name="Rounded Rectangle 7"/>
           <p:cNvSpPr/>
           <p:nvPr/>
         </p:nvSpPr>
         <p:spPr>
           <a:xfrm>
-            <a:off x="731520" y="2688336"/>
-            <a:ext cx="3090672" cy="1234440"/>
+            <a:off x="731520" y="3218688"/>
+            <a:ext cx="3090672" cy="859536"/>
           </a:xfrm>
           <a:prstGeom prst="roundRect">
             <a:avLst>
@@ -13615,14 +13698,14 @@
       </p:sp>
       <p:sp>
         <p:nvSpPr>
-          <p:cNvPr id="8" name="TextBox 7"/>
+          <p:cNvPr id="9" name="TextBox 8"/>
           <p:cNvSpPr txBox="1"/>
           <p:nvPr/>
         </p:nvSpPr>
         <p:spPr>
           <a:xfrm>
-            <a:off x="905256" y="2871216"/>
-            <a:ext cx="2724912" cy="265176"/>
+            <a:off x="877824" y="3355848"/>
+            <a:ext cx="2788920" cy="210312"/>
           </a:xfrm>
           <a:prstGeom prst="rect">
             <a:avLst/>
@@ -13641,27 +13724,27 @@
               </a:spcAft>
             </a:pPr>
             <a:r>
-              <a:rPr sz="1000" b="1">
+              <a:rPr sz="900" b="1">
                 <a:solidFill>
                   <a:srgbClr val="D9EDB7"/>
                 </a:solidFill>
                 <a:latin typeface="Aptos"/>
               </a:rPr>
-              <a:t>CUSTOMER</a:t>
-            </a:r>
-          </a:p>
-        </p:txBody>
-      </p:sp>
-      <p:sp>
-        <p:nvSpPr>
-          <p:cNvPr id="9" name="TextBox 8"/>
+              <a:t>OWNED FACTS</a:t>
+            </a:r>
+          </a:p>
+        </p:txBody>
+      </p:sp>
+      <p:sp>
+        <p:nvSpPr>
+          <p:cNvPr id="10" name="TextBox 9"/>
           <p:cNvSpPr txBox="1"/>
           <p:nvPr/>
         </p:nvSpPr>
         <p:spPr>
           <a:xfrm>
-            <a:off x="905256" y="3364992"/>
-            <a:ext cx="2743200" cy="393192"/>
+            <a:off x="877824" y="3703320"/>
+            <a:ext cx="2788920" cy="265176"/>
           </a:xfrm>
           <a:prstGeom prst="rect">
             <a:avLst/>
@@ -13680,27 +13763,27 @@
               </a:spcAft>
             </a:pPr>
             <a:r>
-              <a:rPr sz="2000" b="1">
+              <a:rPr sz="1600" b="1">
                 <a:solidFill>
                   <a:srgbClr val="F8F8F2"/>
                 </a:solidFill>
                 <a:latin typeface="Aptos"/>
               </a:rPr>
-              <a:t>Voice + text</a:t>
-            </a:r>
-          </a:p>
-        </p:txBody>
-      </p:sp>
-      <p:sp>
-        <p:nvSpPr>
-          <p:cNvPr id="10" name="TextBox 9"/>
+              <a:t>Customer + charge</a:t>
+            </a:r>
+          </a:p>
+        </p:txBody>
+      </p:sp>
+      <p:sp>
+        <p:nvSpPr>
+          <p:cNvPr id="11" name="TextBox 10"/>
           <p:cNvSpPr txBox="1"/>
           <p:nvPr/>
         </p:nvSpPr>
         <p:spPr>
           <a:xfrm>
-            <a:off x="3831336" y="3145536"/>
-            <a:ext cx="228600" cy="457200"/>
+            <a:off x="3831336" y="3557016"/>
+            <a:ext cx="228600" cy="292608"/>
           </a:xfrm>
           <a:prstGeom prst="rect">
             <a:avLst/>
@@ -13719,7 +13802,7 @@
               </a:spcAft>
             </a:pPr>
             <a:r>
-              <a:rPr sz="1600" b="1">
+              <a:rPr sz="1400" b="1">
                 <a:solidFill>
                   <a:srgbClr val="D9EDB7"/>
                 </a:solidFill>
@@ -13732,14 +13815,14 @@
       </p:sp>
       <p:sp>
         <p:nvSpPr>
-          <p:cNvPr id="11" name="Rounded Rectangle 10"/>
+          <p:cNvPr id="12" name="Rounded Rectangle 11"/>
           <p:cNvSpPr/>
           <p:nvPr/>
         </p:nvSpPr>
         <p:spPr>
           <a:xfrm>
-            <a:off x="4069080" y="2688336"/>
-            <a:ext cx="3090672" cy="1234440"/>
+            <a:off x="4069080" y="3218688"/>
+            <a:ext cx="3090672" cy="859536"/>
           </a:xfrm>
           <a:prstGeom prst="roundRect">
             <a:avLst>
@@ -13777,14 +13860,14 @@
       </p:sp>
       <p:sp>
         <p:nvSpPr>
-          <p:cNvPr id="12" name="TextBox 11"/>
+          <p:cNvPr id="13" name="TextBox 12"/>
           <p:cNvSpPr txBox="1"/>
           <p:nvPr/>
         </p:nvSpPr>
         <p:spPr>
           <a:xfrm>
-            <a:off x="4242816" y="2871216"/>
-            <a:ext cx="2724912" cy="265176"/>
+            <a:off x="4215384" y="3355848"/>
+            <a:ext cx="2788920" cy="210312"/>
           </a:xfrm>
           <a:prstGeom prst="rect">
             <a:avLst/>
@@ -13803,27 +13886,27 @@
               </a:spcAft>
             </a:pPr>
             <a:r>
-              <a:rPr sz="1000" b="1">
+              <a:rPr sz="900" b="1">
                 <a:solidFill>
                   <a:srgbClr val="D9EDB7"/>
                 </a:solidFill>
                 <a:latin typeface="Aptos"/>
               </a:rPr>
-              <a:t>SAVIA HOST</a:t>
-            </a:r>
-          </a:p>
-        </p:txBody>
-      </p:sp>
-      <p:sp>
-        <p:nvSpPr>
-          <p:cNvPr id="13" name="TextBox 12"/>
+              <a:t>ORDERED POLICY</a:t>
+            </a:r>
+          </a:p>
+        </p:txBody>
+      </p:sp>
+      <p:sp>
+        <p:nvSpPr>
+          <p:cNvPr id="14" name="TextBox 13"/>
           <p:cNvSpPr txBox="1"/>
           <p:nvPr/>
         </p:nvSpPr>
         <p:spPr>
           <a:xfrm>
-            <a:off x="4242816" y="3364992"/>
-            <a:ext cx="2743200" cy="393192"/>
+            <a:off x="4215384" y="3703320"/>
+            <a:ext cx="2788920" cy="265176"/>
           </a:xfrm>
           <a:prstGeom prst="rect">
             <a:avLst/>
@@ -13842,27 +13925,27 @@
               </a:spcAft>
             </a:pPr>
             <a:r>
-              <a:rPr sz="2000" b="1">
+              <a:rPr sz="1600" b="1">
                 <a:solidFill>
                   <a:srgbClr val="F8F8F2"/>
                 </a:solidFill>
                 <a:latin typeface="Aptos"/>
               </a:rPr>
-              <a:t>Case + consent</a:t>
-            </a:r>
-          </a:p>
-        </p:txBody>
-      </p:sp>
-      <p:sp>
-        <p:nvSpPr>
-          <p:cNvPr id="14" name="TextBox 13"/>
+              <a:t>R0–R18 + consent</a:t>
+            </a:r>
+          </a:p>
+        </p:txBody>
+      </p:sp>
+      <p:sp>
+        <p:nvSpPr>
+          <p:cNvPr id="15" name="TextBox 14"/>
           <p:cNvSpPr txBox="1"/>
           <p:nvPr/>
         </p:nvSpPr>
         <p:spPr>
           <a:xfrm>
-            <a:off x="7168896" y="3145536"/>
-            <a:ext cx="228600" cy="457200"/>
+            <a:off x="7168896" y="3557016"/>
+            <a:ext cx="228600" cy="292608"/>
           </a:xfrm>
           <a:prstGeom prst="rect">
             <a:avLst/>
@@ -13881,7 +13964,7 @@
               </a:spcAft>
             </a:pPr>
             <a:r>
-              <a:rPr sz="1600" b="1">
+              <a:rPr sz="1400" b="1">
                 <a:solidFill>
                   <a:srgbClr val="D9EDB7"/>
                 </a:solidFill>
@@ -13894,14 +13977,14 @@
       </p:sp>
       <p:sp>
         <p:nvSpPr>
-          <p:cNvPr id="15" name="Rounded Rectangle 14"/>
+          <p:cNvPr id="16" name="Rounded Rectangle 15"/>
           <p:cNvSpPr/>
           <p:nvPr/>
         </p:nvSpPr>
         <p:spPr>
           <a:xfrm>
-            <a:off x="7406640" y="2688336"/>
-            <a:ext cx="3090672" cy="1234440"/>
+            <a:off x="7406640" y="3218688"/>
+            <a:ext cx="3090672" cy="859536"/>
           </a:xfrm>
           <a:prstGeom prst="roundRect">
             <a:avLst>
@@ -13939,14 +14022,14 @@
       </p:sp>
       <p:sp>
         <p:nvSpPr>
-          <p:cNvPr id="16" name="TextBox 15"/>
+          <p:cNvPr id="17" name="TextBox 16"/>
           <p:cNvSpPr txBox="1"/>
           <p:nvPr/>
         </p:nvSpPr>
         <p:spPr>
           <a:xfrm>
-            <a:off x="7580375" y="2871216"/>
-            <a:ext cx="2724912" cy="265176"/>
+            <a:off x="7552944" y="3355848"/>
+            <a:ext cx="2788920" cy="210312"/>
           </a:xfrm>
           <a:prstGeom prst="rect">
             <a:avLst/>
@@ -13965,27 +14048,27 @@
               </a:spcAft>
             </a:pPr>
             <a:r>
-              <a:rPr sz="1000" b="1">
+              <a:rPr sz="900" b="1">
                 <a:solidFill>
                   <a:srgbClr val="D9EDB7"/>
                 </a:solidFill>
                 <a:latin typeface="Aptos"/>
               </a:rPr>
-              <a:t>FLUJO</a:t>
-            </a:r>
-          </a:p>
-        </p:txBody>
-      </p:sp>
-      <p:sp>
-        <p:nvSpPr>
-          <p:cNvPr id="17" name="TextBox 16"/>
+              <a:t>VERIFIED RECEIPT</a:t>
+            </a:r>
+          </a:p>
+        </p:txBody>
+      </p:sp>
+      <p:sp>
+        <p:nvSpPr>
+          <p:cNvPr id="18" name="TextBox 17"/>
           <p:cNvSpPr txBox="1"/>
           <p:nvPr/>
         </p:nvSpPr>
         <p:spPr>
           <a:xfrm>
-            <a:off x="7580375" y="3364992"/>
-            <a:ext cx="2743200" cy="393192"/>
+            <a:off x="7552944" y="3703320"/>
+            <a:ext cx="2788920" cy="265176"/>
           </a:xfrm>
           <a:prstGeom prst="rect">
             <a:avLst/>
@@ -14004,27 +14087,27 @@
               </a:spcAft>
             </a:pPr>
             <a:r>
-              <a:rPr sz="2000" b="1">
+              <a:rPr sz="1600" b="1">
                 <a:solidFill>
                   <a:srgbClr val="F8F8F2"/>
                 </a:solidFill>
                 <a:latin typeface="Aptos"/>
               </a:rPr>
-              <a:t>Agents + statistics</a:t>
-            </a:r>
-          </a:p>
-        </p:txBody>
-      </p:sp>
-      <p:sp>
-        <p:nvSpPr>
-          <p:cNvPr id="18" name="TextBox 17"/>
+              <a:t>Readback + recovery</a:t>
+            </a:r>
+          </a:p>
+        </p:txBody>
+      </p:sp>
+      <p:sp>
+        <p:nvSpPr>
+          <p:cNvPr id="19" name="TextBox 18"/>
           <p:cNvSpPr txBox="1"/>
           <p:nvPr/>
         </p:nvSpPr>
         <p:spPr>
           <a:xfrm>
-            <a:off x="10506456" y="3145536"/>
-            <a:ext cx="228600" cy="457200"/>
+            <a:off x="10506456" y="3557016"/>
+            <a:ext cx="228600" cy="292608"/>
           </a:xfrm>
           <a:prstGeom prst="rect">
             <a:avLst/>
@@ -14043,7 +14126,7 @@
               </a:spcAft>
             </a:pPr>
             <a:r>
-              <a:rPr sz="1600" b="1">
+              <a:rPr sz="1400" b="1">
                 <a:solidFill>
                   <a:srgbClr val="D9EDB7"/>
                 </a:solidFill>
@@ -14056,14 +14139,14 @@
       </p:sp>
       <p:sp>
         <p:nvSpPr>
-          <p:cNvPr id="19" name="Rounded Rectangle 18"/>
+          <p:cNvPr id="20" name="Rounded Rectangle 19"/>
           <p:cNvSpPr/>
           <p:nvPr/>
         </p:nvSpPr>
         <p:spPr>
           <a:xfrm>
-            <a:off x="10744200" y="2688336"/>
-            <a:ext cx="3090672" cy="1234440"/>
+            <a:off x="10744200" y="3218688"/>
+            <a:ext cx="3090672" cy="859536"/>
           </a:xfrm>
           <a:prstGeom prst="roundRect">
             <a:avLst>
@@ -14101,14 +14184,14 @@
       </p:sp>
       <p:sp>
         <p:nvSpPr>
-          <p:cNvPr id="20" name="TextBox 19"/>
+          <p:cNvPr id="21" name="TextBox 20"/>
           <p:cNvSpPr txBox="1"/>
           <p:nvPr/>
         </p:nvSpPr>
         <p:spPr>
           <a:xfrm>
-            <a:off x="10917936" y="2871216"/>
-            <a:ext cx="2724912" cy="265176"/>
+            <a:off x="10890504" y="3355848"/>
+            <a:ext cx="2788920" cy="210312"/>
           </a:xfrm>
           <a:prstGeom prst="rect">
             <a:avLst/>
@@ -14127,27 +14210,27 @@
               </a:spcAft>
             </a:pPr>
             <a:r>
-              <a:rPr sz="1000" b="1">
+              <a:rPr sz="900" b="1">
                 <a:solidFill>
                   <a:srgbClr val="D9EDB7"/>
                 </a:solidFill>
                 <a:latin typeface="Aptos"/>
               </a:rPr>
-              <a:t>BANKING MCP</a:t>
-            </a:r>
-          </a:p>
-        </p:txBody>
-      </p:sp>
-      <p:sp>
-        <p:nvSpPr>
-          <p:cNvPr id="21" name="TextBox 20"/>
+              <a:t>SAVED FOLLOW-UP</a:t>
+            </a:r>
+          </a:p>
+        </p:txBody>
+      </p:sp>
+      <p:sp>
+        <p:nvSpPr>
+          <p:cNvPr id="22" name="TextBox 21"/>
           <p:cNvSpPr txBox="1"/>
           <p:nvPr/>
         </p:nvSpPr>
         <p:spPr>
           <a:xfrm>
-            <a:off x="10917936" y="3364992"/>
-            <a:ext cx="2743200" cy="393192"/>
+            <a:off x="10890504" y="3703320"/>
+            <a:ext cx="2788920" cy="265176"/>
           </a:xfrm>
           <a:prstGeom prst="rect">
             <a:avLst/>
@@ -14166,27 +14249,72 @@
               </a:spcAft>
             </a:pPr>
             <a:r>
-              <a:rPr sz="2000" b="1">
+              <a:rPr sz="1600" b="1">
                 <a:solidFill>
                   <a:srgbClr val="F8F8F2"/>
                 </a:solidFill>
                 <a:latin typeface="Aptos"/>
               </a:rPr>
-              <a:t>Scoped data + tools</a:t>
-            </a:r>
-          </a:p>
-        </p:txBody>
-      </p:sp>
-      <p:sp>
-        <p:nvSpPr>
-          <p:cNvPr id="22" name="TextBox 21"/>
+              <a:t>Context + handoff</a:t>
+            </a:r>
+          </a:p>
+        </p:txBody>
+      </p:sp>
+      <p:sp>
+        <p:nvSpPr>
+          <p:cNvPr id="23" name="Rounded Rectangle 22"/>
+          <p:cNvSpPr/>
+          <p:nvPr/>
+        </p:nvSpPr>
+        <p:spPr>
+          <a:xfrm>
+            <a:off x="731520" y="4325112"/>
+            <a:ext cx="4206240" cy="1755648"/>
+          </a:xfrm>
+          <a:prstGeom prst="roundRect">
+            <a:avLst>
+              <a:gd name="adj" fmla="val 12000"/>
+            </a:avLst>
+          </a:prstGeom>
+          <a:solidFill>
+            <a:srgbClr val="214A3F"/>
+          </a:solidFill>
+          <a:ln>
+            <a:noFill/>
+          </a:ln>
+        </p:spPr>
+        <p:style>
+          <a:lnRef idx="1">
+            <a:schemeClr val="accent1"/>
+          </a:lnRef>
+          <a:fillRef idx="3">
+            <a:schemeClr val="accent1"/>
+          </a:fillRef>
+          <a:effectRef idx="2">
+            <a:schemeClr val="accent1"/>
+          </a:effectRef>
+          <a:fontRef idx="minor">
+            <a:schemeClr val="lt1"/>
+          </a:fontRef>
+        </p:style>
+        <p:txBody>
+          <a:bodyPr rtlCol="0" anchor="ctr"/>
+          <a:lstStyle/>
+          <a:p>
+            <a:pPr algn="ctr"/>
+          </a:p>
+        </p:txBody>
+      </p:sp>
+      <p:sp>
+        <p:nvSpPr>
+          <p:cNvPr id="24" name="TextBox 23"/>
           <p:cNvSpPr txBox="1"/>
           <p:nvPr/>
         </p:nvSpPr>
         <p:spPr>
           <a:xfrm>
-            <a:off x="777240" y="4133087"/>
-            <a:ext cx="13167360" cy="283464"/>
+            <a:off x="905256" y="4471416"/>
+            <a:ext cx="3849624" cy="530352"/>
           </a:xfrm>
           <a:prstGeom prst="rect">
             <a:avLst/>
@@ -14205,98 +14333,14 @@
               </a:spcAft>
             </a:pPr>
             <a:r>
-              <a:rPr sz="1600" b="0">
-                <a:solidFill>
-                  <a:srgbClr val="C6D3CA"/>
-                </a:solidFill>
-                <a:latin typeface="Aptos"/>
-              </a:rPr>
-              <a:t>TLS ingress · separated data and state · authority stays in Savia + Banking MCP</a:t>
-            </a:r>
-          </a:p>
-        </p:txBody>
-      </p:sp>
-      <p:sp>
-        <p:nvSpPr>
-          <p:cNvPr id="23" name="TextBox 22"/>
-          <p:cNvSpPr txBox="1"/>
-          <p:nvPr/>
-        </p:nvSpPr>
-        <p:spPr>
-          <a:xfrm>
-            <a:off x="777240" y="4663440"/>
-            <a:ext cx="13167360" cy="329184"/>
-          </a:xfrm>
-          <a:prstGeom prst="rect">
-            <a:avLst/>
-          </a:prstGeom>
-          <a:noFill/>
-        </p:spPr>
-        <p:txBody>
-          <a:bodyPr wrap="square" lIns="9144" rIns="9144" tIns="0" bIns="0" anchor="t">
-            <a:spAutoFit/>
-          </a:bodyPr>
-          <a:lstStyle/>
-          <a:p>
-            <a:pPr>
-              <a:spcAft>
-                <a:spcPts val="200"/>
-              </a:spcAft>
-            </a:pPr>
-            <a:r>
-              <a:rPr sz="1600" b="1">
+              <a:rPr sz="3200" b="1">
                 <a:solidFill>
                   <a:srgbClr val="D9EDB7"/>
                 </a:solidFill>
                 <a:latin typeface="Aptos"/>
               </a:rPr>
-              <a:t>Self-hostable foundation · local open-weight model option · interchangeable MCP / model modules</a:t>
-            </a:r>
-          </a:p>
-        </p:txBody>
-      </p:sp>
-      <p:sp>
-        <p:nvSpPr>
-          <p:cNvPr id="24" name="Rounded Rectangle 23"/>
-          <p:cNvSpPr/>
-          <p:nvPr/>
-        </p:nvSpPr>
-        <p:spPr>
-          <a:xfrm>
-            <a:off x="731520" y="5367528"/>
-            <a:ext cx="4206240" cy="1719072"/>
-          </a:xfrm>
-          <a:prstGeom prst="roundRect">
-            <a:avLst>
-              <a:gd name="adj" fmla="val 12000"/>
-            </a:avLst>
-          </a:prstGeom>
-          <a:solidFill>
-            <a:srgbClr val="214A3F"/>
-          </a:solidFill>
-          <a:ln>
-            <a:noFill/>
-          </a:ln>
-        </p:spPr>
-        <p:style>
-          <a:lnRef idx="1">
-            <a:schemeClr val="accent1"/>
-          </a:lnRef>
-          <a:fillRef idx="3">
-            <a:schemeClr val="accent1"/>
-          </a:fillRef>
-          <a:effectRef idx="2">
-            <a:schemeClr val="accent1"/>
-          </a:effectRef>
-          <a:fontRef idx="minor">
-            <a:schemeClr val="lt1"/>
-          </a:fontRef>
-        </p:style>
-        <p:txBody>
-          <a:bodyPr rtlCol="0" anchor="ctr"/>
-          <a:lstStyle/>
-          <a:p>
-            <a:pPr algn="ctr"/>
+              <a:t>1,078</a:t>
+            </a:r>
           </a:p>
         </p:txBody>
       </p:sp>
@@ -14308,47 +14352,8 @@
         </p:nvSpPr>
         <p:spPr>
           <a:xfrm>
-            <a:off x="905256" y="5541264"/>
-            <a:ext cx="3849624" cy="566928"/>
-          </a:xfrm>
-          <a:prstGeom prst="rect">
-            <a:avLst/>
-          </a:prstGeom>
-          <a:noFill/>
-        </p:spPr>
-        <p:txBody>
-          <a:bodyPr wrap="square" lIns="9144" rIns="9144" tIns="0" bIns="0" anchor="t">
-            <a:spAutoFit/>
-          </a:bodyPr>
-          <a:lstStyle/>
-          <a:p>
-            <a:pPr>
-              <a:spcAft>
-                <a:spcPts val="200"/>
-              </a:spcAft>
-            </a:pPr>
-            <a:r>
-              <a:rPr sz="3000" b="1">
-                <a:solidFill>
-                  <a:srgbClr val="D9EDB7"/>
-                </a:solidFill>
-                <a:latin typeface="Aptos"/>
-              </a:rPr>
-              <a:t>300/300</a:t>
-            </a:r>
-          </a:p>
-        </p:txBody>
-      </p:sp>
-      <p:sp>
-        <p:nvSpPr>
-          <p:cNvPr id="26" name="TextBox 25"/>
-          <p:cNvSpPr txBox="1"/>
-          <p:nvPr/>
-        </p:nvSpPr>
-        <p:spPr>
-          <a:xfrm>
-            <a:off x="905256" y="6181344"/>
-            <a:ext cx="3849624" cy="274320"/>
+            <a:off x="905256" y="5084064"/>
+            <a:ext cx="3849624" cy="256032"/>
           </a:xfrm>
           <a:prstGeom prst="rect">
             <a:avLst/>
@@ -14373,21 +14378,21 @@
                 </a:solidFill>
                 <a:latin typeface="Aptos"/>
               </a:rPr>
-              <a:t>correct FLUJO reference returns</a:t>
-            </a:r>
-          </a:p>
-        </p:txBody>
-      </p:sp>
-      <p:sp>
-        <p:nvSpPr>
-          <p:cNvPr id="27" name="TextBox 26"/>
+              <a:t>offline core checks</a:t>
+            </a:r>
+          </a:p>
+        </p:txBody>
+      </p:sp>
+      <p:sp>
+        <p:nvSpPr>
+          <p:cNvPr id="26" name="TextBox 25"/>
           <p:cNvSpPr txBox="1"/>
           <p:nvPr/>
         </p:nvSpPr>
         <p:spPr>
           <a:xfrm>
-            <a:off x="905256" y="6583680"/>
-            <a:ext cx="3849624" cy="438912"/>
+            <a:off x="905256" y="5477256"/>
+            <a:ext cx="3849624" cy="429768"/>
           </a:xfrm>
           <a:prstGeom prst="rect">
             <a:avLst/>
@@ -14412,7 +14417,7 @@
                 </a:solidFill>
                 <a:latin typeface="Aptos"/>
               </a:rPr>
-              <a:t>300 queued 1k requests; repeat run</a:t>
+              <a:t>R0–R18, ownership, consent,</a:t>
             </a:r>
           </a:p>
           <a:p>
@@ -14428,21 +14433,21 @@
                 </a:solidFill>
                 <a:latin typeface="Aptos"/>
               </a:rPr>
-              <a:t>p50 273 s / p95 442 s</a:t>
-            </a:r>
-          </a:p>
-        </p:txBody>
-      </p:sp>
-      <p:sp>
-        <p:nvSpPr>
-          <p:cNvPr id="28" name="Rounded Rectangle 27"/>
+              <a:t>receipts and recovery</a:t>
+            </a:r>
+          </a:p>
+        </p:txBody>
+      </p:sp>
+      <p:sp>
+        <p:nvSpPr>
+          <p:cNvPr id="27" name="Rounded Rectangle 26"/>
           <p:cNvSpPr/>
           <p:nvPr/>
         </p:nvSpPr>
         <p:spPr>
           <a:xfrm>
-            <a:off x="5157216" y="5367528"/>
-            <a:ext cx="4206240" cy="1719072"/>
+            <a:off x="5157216" y="4325112"/>
+            <a:ext cx="4206240" cy="1755648"/>
           </a:xfrm>
           <a:prstGeom prst="roundRect">
             <a:avLst>
@@ -14480,14 +14485,14 @@
       </p:sp>
       <p:sp>
         <p:nvSpPr>
-          <p:cNvPr id="29" name="TextBox 28"/>
+          <p:cNvPr id="28" name="TextBox 27"/>
           <p:cNvSpPr txBox="1"/>
           <p:nvPr/>
         </p:nvSpPr>
         <p:spPr>
           <a:xfrm>
-            <a:off x="5330952" y="5541264"/>
-            <a:ext cx="3849624" cy="566928"/>
+            <a:off x="5330952" y="4471416"/>
+            <a:ext cx="3849624" cy="530352"/>
           </a:xfrm>
           <a:prstGeom prst="rect">
             <a:avLst/>
@@ -14506,27 +14511,27 @@
               </a:spcAft>
             </a:pPr>
             <a:r>
-              <a:rPr sz="3000" b="1">
+              <a:rPr sz="3200" b="1">
                 <a:solidFill>
                   <a:srgbClr val="D9EDB7"/>
                 </a:solidFill>
                 <a:latin typeface="Aptos"/>
               </a:rPr>
-              <a:t>129 / 367</a:t>
-            </a:r>
-          </a:p>
-        </p:txBody>
-      </p:sp>
-      <p:sp>
-        <p:nvSpPr>
-          <p:cNvPr id="30" name="TextBox 29"/>
+              <a:t>100 / 100</a:t>
+            </a:r>
+          </a:p>
+        </p:txBody>
+      </p:sp>
+      <p:sp>
+        <p:nvSpPr>
+          <p:cNvPr id="29" name="TextBox 28"/>
           <p:cNvSpPr txBox="1"/>
           <p:nvPr/>
         </p:nvSpPr>
         <p:spPr>
           <a:xfrm>
-            <a:off x="5330952" y="6181344"/>
-            <a:ext cx="3849624" cy="274320"/>
+            <a:off x="5330952" y="5084064"/>
+            <a:ext cx="3849624" cy="256032"/>
           </a:xfrm>
           <a:prstGeom prst="rect">
             <a:avLst/>
@@ -14551,21 +14556,21 @@
                 </a:solidFill>
                 <a:latin typeface="Aptos"/>
               </a:rPr>
-              <a:t>frontend / backend tests</a:t>
-            </a:r>
-          </a:p>
-        </p:txBody>
-      </p:sp>
-      <p:sp>
-        <p:nvSpPr>
-          <p:cNvPr id="31" name="TextBox 30"/>
+              <a:t>local Luna fixture decisions</a:t>
+            </a:r>
+          </a:p>
+        </p:txBody>
+      </p:sp>
+      <p:sp>
+        <p:nvSpPr>
+          <p:cNvPr id="30" name="TextBox 29"/>
           <p:cNvSpPr txBox="1"/>
           <p:nvPr/>
         </p:nvSpPr>
         <p:spPr>
           <a:xfrm>
-            <a:off x="5330952" y="6583680"/>
-            <a:ext cx="3849624" cy="438912"/>
+            <a:off x="5330952" y="5477256"/>
+            <a:ext cx="3849624" cy="429768"/>
           </a:xfrm>
           <a:prstGeom prst="rect">
             <a:avLst/>
@@ -14590,7 +14595,7 @@
                 </a:solidFill>
                 <a:latin typeface="Aptos"/>
               </a:rPr>
-              <a:t>Recorded frozen rc.1 checks</a:t>
+              <a:t>50 ES + 50 PT</a:t>
             </a:r>
           </a:p>
           <a:p>
@@ -14606,21 +14611,21 @@
                 </a:solidFill>
                 <a:latin typeface="Aptos"/>
               </a:rPr>
-              <a:t>Build + ownership + recovery coverage</a:t>
-            </a:r>
-          </a:p>
-        </p:txBody>
-      </p:sp>
-      <p:sp>
-        <p:nvSpPr>
-          <p:cNvPr id="32" name="Rounded Rectangle 31"/>
+              <a:t>Grounded expected decisions</a:t>
+            </a:r>
+          </a:p>
+        </p:txBody>
+      </p:sp>
+      <p:sp>
+        <p:nvSpPr>
+          <p:cNvPr id="31" name="Rounded Rectangle 30"/>
           <p:cNvSpPr/>
           <p:nvPr/>
         </p:nvSpPr>
         <p:spPr>
           <a:xfrm>
-            <a:off x="9582912" y="5367528"/>
-            <a:ext cx="4206240" cy="1719072"/>
+            <a:off x="9582912" y="4325112"/>
+            <a:ext cx="4206240" cy="1755648"/>
           </a:xfrm>
           <a:prstGeom prst="roundRect">
             <a:avLst>
@@ -14658,14 +14663,14 @@
       </p:sp>
       <p:sp>
         <p:nvSpPr>
-          <p:cNvPr id="33" name="TextBox 32"/>
+          <p:cNvPr id="32" name="TextBox 31"/>
           <p:cNvSpPr txBox="1"/>
           <p:nvPr/>
         </p:nvSpPr>
         <p:spPr>
           <a:xfrm>
-            <a:off x="9756648" y="5541264"/>
-            <a:ext cx="3849624" cy="566928"/>
+            <a:off x="9756648" y="4471416"/>
+            <a:ext cx="3849624" cy="530352"/>
           </a:xfrm>
           <a:prstGeom prst="rect">
             <a:avLst/>
@@ -14684,27 +14689,27 @@
               </a:spcAft>
             </a:pPr>
             <a:r>
-              <a:rPr sz="2300" b="1">
+              <a:rPr sz="3200" b="1">
                 <a:solidFill>
                   <a:srgbClr val="D9EDB7"/>
                 </a:solidFill>
                 <a:latin typeface="Aptos"/>
               </a:rPr>
-              <a:t>Run → tool → agent</a:t>
-            </a:r>
-          </a:p>
-        </p:txBody>
-      </p:sp>
-      <p:sp>
-        <p:nvSpPr>
-          <p:cNvPr id="34" name="TextBox 33"/>
+              <a:t>2 journeys</a:t>
+            </a:r>
+          </a:p>
+        </p:txBody>
+      </p:sp>
+      <p:sp>
+        <p:nvSpPr>
+          <p:cNvPr id="33" name="TextBox 32"/>
           <p:cNvSpPr txBox="1"/>
           <p:nvPr/>
         </p:nvSpPr>
         <p:spPr>
           <a:xfrm>
-            <a:off x="9756648" y="6181344"/>
-            <a:ext cx="3849624" cy="274320"/>
+            <a:off x="9756648" y="5084064"/>
+            <a:ext cx="3849624" cy="256032"/>
           </a:xfrm>
           <a:prstGeom prst="rect">
             <a:avLst/>
@@ -14729,21 +14734,21 @@
                 </a:solidFill>
                 <a:latin typeface="Aptos"/>
               </a:rPr>
-              <a:t>execution visibility</a:t>
-            </a:r>
-          </a:p>
-        </p:txBody>
-      </p:sp>
-      <p:sp>
-        <p:nvSpPr>
-          <p:cNvPr id="35" name="TextBox 34"/>
+              <a:t>live public API · card protection</a:t>
+            </a:r>
+          </a:p>
+        </p:txBody>
+      </p:sp>
+      <p:sp>
+        <p:nvSpPr>
+          <p:cNvPr id="34" name="TextBox 33"/>
           <p:cNvSpPr txBox="1"/>
           <p:nvPr/>
         </p:nvSpPr>
         <p:spPr>
           <a:xfrm>
-            <a:off x="9756648" y="6583680"/>
-            <a:ext cx="3849624" cy="438912"/>
+            <a:off x="9756648" y="5477256"/>
+            <a:ext cx="3849624" cy="429768"/>
           </a:xfrm>
           <a:prstGeom prst="rect">
             <a:avLst/>
@@ -14768,7 +14773,7 @@
                 </a:solidFill>
                 <a:latin typeface="Aptos"/>
               </a:rPr>
-              <a:t>FLUJO metadata statistics</a:t>
+              <a:t>Spanish + Portuguese: consent,</a:t>
             </a:r>
           </a:p>
           <a:p>
@@ -14784,8 +14789,53 @@
                 </a:solidFill>
                 <a:latin typeface="Aptos"/>
               </a:rPr>
-              <a:t>Durations, tokens, failures, revisions</a:t>
-            </a:r>
+              <a:t>verified block and status on new login</a:t>
+            </a:r>
+          </a:p>
+        </p:txBody>
+      </p:sp>
+      <p:sp>
+        <p:nvSpPr>
+          <p:cNvPr id="35" name="Rounded Rectangle 34"/>
+          <p:cNvSpPr/>
+          <p:nvPr/>
+        </p:nvSpPr>
+        <p:spPr>
+          <a:xfrm>
+            <a:off x="731520" y="6327648"/>
+            <a:ext cx="13057632" cy="914400"/>
+          </a:xfrm>
+          <a:prstGeom prst="roundRect">
+            <a:avLst>
+              <a:gd name="adj" fmla="val 12000"/>
+            </a:avLst>
+          </a:prstGeom>
+          <a:solidFill>
+            <a:srgbClr val="214A3F"/>
+          </a:solidFill>
+          <a:ln>
+            <a:noFill/>
+          </a:ln>
+        </p:spPr>
+        <p:style>
+          <a:lnRef idx="1">
+            <a:schemeClr val="accent1"/>
+          </a:lnRef>
+          <a:fillRef idx="3">
+            <a:schemeClr val="accent1"/>
+          </a:fillRef>
+          <a:effectRef idx="2">
+            <a:schemeClr val="accent1"/>
+          </a:effectRef>
+          <a:fontRef idx="minor">
+            <a:schemeClr val="lt1"/>
+          </a:fontRef>
+        </p:style>
+        <p:txBody>
+          <a:bodyPr rtlCol="0" anchor="ctr"/>
+          <a:lstStyle/>
+          <a:p>
+            <a:pPr algn="ctr"/>
           </a:p>
         </p:txBody>
       </p:sp>
@@ -14797,8 +14847,86 @@
         </p:nvSpPr>
         <p:spPr>
           <a:xfrm>
-            <a:off x="749808" y="7306056"/>
-            <a:ext cx="13167360" cy="338328"/>
+            <a:off x="914400" y="6455664"/>
+            <a:ext cx="12664440" cy="192024"/>
+          </a:xfrm>
+          <a:prstGeom prst="rect">
+            <a:avLst/>
+          </a:prstGeom>
+          <a:noFill/>
+        </p:spPr>
+        <p:txBody>
+          <a:bodyPr wrap="square" lIns="9144" rIns="9144" tIns="0" bIns="0" anchor="t">
+            <a:spAutoFit/>
+          </a:bodyPr>
+          <a:lstStyle/>
+          <a:p>
+            <a:pPr>
+              <a:spcAft>
+                <a:spcPts val="200"/>
+              </a:spcAft>
+            </a:pPr>
+            <a:r>
+              <a:rPr sz="900" b="1">
+                <a:solidFill>
+                  <a:srgbClr val="D9EDB7"/>
+                </a:solidFill>
+                <a:latin typeface="Aptos"/>
+              </a:rPr>
+              <a:t>DATA → PRODUCT DECISION</a:t>
+            </a:r>
+          </a:p>
+        </p:txBody>
+      </p:sp>
+      <p:sp>
+        <p:nvSpPr>
+          <p:cNvPr id="37" name="TextBox 36"/>
+          <p:cNvSpPr txBox="1"/>
+          <p:nvPr/>
+        </p:nvSpPr>
+        <p:spPr>
+          <a:xfrm>
+            <a:off x="914400" y="6766560"/>
+            <a:ext cx="12664440" cy="256032"/>
+          </a:xfrm>
+          <a:prstGeom prst="rect">
+            <a:avLst/>
+          </a:prstGeom>
+          <a:noFill/>
+        </p:spPr>
+        <p:txBody>
+          <a:bodyPr wrap="square" lIns="9144" rIns="9144" tIns="0" bIns="0" anchor="t">
+            <a:spAutoFit/>
+          </a:bodyPr>
+          <a:lstStyle/>
+          <a:p>
+            <a:pPr>
+              <a:spcAft>
+                <a:spcPts val="200"/>
+              </a:spcAft>
+            </a:pPr>
+            <a:r>
+              <a:rPr sz="1700" b="1">
+                <a:solidFill>
+                  <a:srgbClr val="F8F8F2"/>
+                </a:solidFill>
+                <a:latin typeface="Aptos"/>
+              </a:rPr>
+              <a:t>Historical links crossed customer ownership. New inquiries use owned transaction reads.</a:t>
+            </a:r>
+          </a:p>
+        </p:txBody>
+      </p:sp>
+      <p:sp>
+        <p:nvSpPr>
+          <p:cNvPr id="38" name="TextBox 37"/>
+          <p:cNvSpPr txBox="1"/>
+          <p:nvPr/>
+        </p:nvSpPr>
+        <p:spPr>
+          <a:xfrm>
+            <a:off x="749808" y="7434072"/>
+            <a:ext cx="13167360" cy="210312"/>
           </a:xfrm>
           <a:prstGeom prst="rect">
             <a:avLst/>
@@ -14823,46 +14951,7 @@
                 </a:solidFill>
                 <a:latin typeface="Aptos"/>
               </a:rPr>
-              <a:t>Benchmark: Qwen3.8-27B FP8 + vLLM on rented H100. Current demo: direct provider; FLUJO fleet is the integration target.</a:t>
-            </a:r>
-          </a:p>
-        </p:txBody>
-      </p:sp>
-      <p:sp>
-        <p:nvSpPr>
-          <p:cNvPr id="37" name="TextBox 36"/>
-          <p:cNvSpPr txBox="1"/>
-          <p:nvPr/>
-        </p:nvSpPr>
-        <p:spPr>
-          <a:xfrm>
-            <a:off x="749808" y="7534656"/>
-            <a:ext cx="13167360" cy="210312"/>
-          </a:xfrm>
-          <a:prstGeom prst="rect">
-            <a:avLst/>
-          </a:prstGeom>
-          <a:noFill/>
-        </p:spPr>
-        <p:txBody>
-          <a:bodyPr wrap="square" lIns="9144" rIns="9144" tIns="0" bIns="0" anchor="t">
-            <a:spAutoFit/>
-          </a:bodyPr>
-          <a:lstStyle/>
-          <a:p>
-            <a:pPr>
-              <a:spcAft>
-                <a:spcPts val="200"/>
-              </a:spcAft>
-            </a:pPr>
-            <a:r>
-              <a:rPr sz="900" b="0">
-                <a:solidFill>
-                  <a:srgbClr val="C6D3CA"/>
-                </a:solidFill>
-                <a:latin typeface="Aptos"/>
-              </a:rPr>
-              <a:t>Case state persists; active audio resets after restart. Capacity is a workload result, not 300 simultaneous GPU generations.</a:t>
+              <a:t>Savia + Banking MCP own the banking boundary. FLUJO keeps its generic interfaces; voice and models remain replaceable.</a:t>
             </a:r>
           </a:p>
         </p:txBody>
@@ -15009,7 +15098,7 @@
                 </a:solidFill>
                 <a:latin typeface="Aptos"/>
               </a:rPr>
-              <a:t>SAVIA  /  ONE VOICE. A NETWORK BEHIND IT.</a:t>
+              <a:t>SAVIA  /  ASK ONCE. SAVIA FOLLOWS THROUGH.</a:t>
             </a:r>
           </a:p>
         </p:txBody>

</xml_diff>